<commit_message>
polish paper-study deck title and layout
</commit_message>
<xml_diff>
--- a/presentation/mt_bench_paper_study.pptx
+++ b/presentation/mt_bench_paper_study.pptx
@@ -6100,8 +6100,8 @@
         </p:nvSpPr>
         <p:spPr>
           <a:xfrm>
-            <a:off x="713232" y="786384"/>
-            <a:ext cx="5303520" cy="1353312"/>
+            <a:off x="713232" y="749808"/>
+            <a:ext cx="5376672" cy="1554480"/>
           </a:xfrm>
           <a:prstGeom prst="rect">
             <a:avLst/>
@@ -6113,20 +6113,21 @@
         </p:spPr>
         <p:txBody>
           <a:bodyPr wrap="square" lIns="0" rIns="0" tIns="0" bIns="0" anchor="t">
-            <a:spAutoFit/>
+            <a:normAutofit/>
           </a:bodyPr>
           <a:lstStyle/>
           <a:p>
             <a:pPr algn="l"/>
             <a:r>
-              <a:rPr sz="3000" b="1">
+              <a:rPr sz="2700" b="1">
                 <a:solidFill>
                   <a:srgbClr val="282C3A"/>
                 </a:solidFill>
                 <a:latin typeface="Apple SD Gothic Neo"/>
               </a:rPr>
-              <a:t>MT-Bench / Chatbot Arena
-논문 리뷰와 내 연구</a:t>
+              <a:t>Judging LLM-as-a-Judge
+with MT-Bench
+and Chatbot Arena</a:t>
             </a:r>
           </a:p>
         </p:txBody>
@@ -6139,8 +6140,8 @@
         </p:nvSpPr>
         <p:spPr>
           <a:xfrm>
-            <a:off x="731520" y="2395728"/>
-            <a:ext cx="4937760" cy="274320"/>
+            <a:off x="731520" y="2542032"/>
+            <a:ext cx="4846320" cy="256032"/>
           </a:xfrm>
           <a:prstGeom prst="rect">
             <a:avLst/>
@@ -6152,7 +6153,7 @@
         </p:spPr>
         <p:txBody>
           <a:bodyPr wrap="square" lIns="0" rIns="0" tIns="0" bIns="0" anchor="t">
-            <a:spAutoFit/>
+            <a:normAutofit/>
           </a:bodyPr>
           <a:lstStyle/>
           <a:p>
@@ -6164,7 +6165,7 @@
                 </a:solidFill>
                 <a:latin typeface="Apple SD Gothic Neo"/>
               </a:rPr>
-              <a:t>1부 논문 리뷰, 2부 내 연구</a:t>
+              <a:t>논문 스터디</a:t>
             </a:r>
           </a:p>
         </p:txBody>
@@ -6177,8 +6178,8 @@
         </p:nvSpPr>
         <p:spPr>
           <a:xfrm>
-            <a:off x="731520" y="2871216"/>
-            <a:ext cx="5029200" cy="1234440"/>
+            <a:off x="731520" y="2926080"/>
+            <a:ext cx="5074920" cy="960120"/>
           </a:xfrm>
           <a:prstGeom prst="rect">
             <a:avLst/>
@@ -6190,20 +6191,20 @@
         </p:spPr>
         <p:txBody>
           <a:bodyPr wrap="square" lIns="64008" rIns="64008" tIns="64008" bIns="64008" anchor="t">
-            <a:spAutoFit/>
+            <a:normAutofit/>
           </a:bodyPr>
           <a:lstStyle/>
           <a:p>
             <a:pPr algn="l"/>
             <a:r>
-              <a:rPr sz="1800" b="0">
+              <a:rPr sz="1600" b="0">
                 <a:solidFill>
                   <a:srgbClr val="363A48"/>
                 </a:solidFill>
                 <a:latin typeface="Apple SD Gothic Neo"/>
               </a:rPr>
-              <a:t>앞 절반은 Zheng et al.의 베이스 논문을 읽는 시간입니다.
-뒤 절반은 그 프로토콜을 제 저장소와 실험으로 어떻게 옮겼는지 설명합니다.</a:t>
+              <a:t>앞 절반은 원 논문의 설계와 메시지를 읽고,
+뒤 절반은 그 프로토콜을 내 오픈소스 judge 실험으로 어떻게 옮겼는지 설명합니다.</a:t>
             </a:r>
           </a:p>
         </p:txBody>
@@ -6229,7 +6230,7 @@
         </p:spPr>
         <p:txBody>
           <a:bodyPr wrap="square" lIns="0" rIns="0" tIns="0" bIns="0" anchor="t">
-            <a:spAutoFit/>
+            <a:normAutofit/>
           </a:bodyPr>
           <a:lstStyle/>
           <a:p>
@@ -6315,7 +6316,7 @@
         </p:spPr>
         <p:txBody>
           <a:bodyPr wrap="square" lIns="0" rIns="0" tIns="0" bIns="0" anchor="t">
-            <a:spAutoFit/>
+            <a:normAutofit/>
           </a:bodyPr>
           <a:lstStyle/>
           <a:p>
@@ -6353,7 +6354,7 @@
         </p:spPr>
         <p:txBody>
           <a:bodyPr wrap="square" lIns="0" rIns="0" tIns="0" bIns="0" anchor="t">
-            <a:spAutoFit/>
+            <a:normAutofit/>
           </a:bodyPr>
           <a:lstStyle/>
           <a:p>
@@ -6391,19 +6392,19 @@
         </p:spPr>
         <p:txBody>
           <a:bodyPr wrap="square" lIns="0" rIns="0" tIns="0" bIns="0" anchor="t">
-            <a:spAutoFit/>
+            <a:normAutofit/>
           </a:bodyPr>
           <a:lstStyle/>
           <a:p>
             <a:pPr algn="l"/>
             <a:r>
-              <a:rPr sz="1600" b="1">
+              <a:rPr sz="1500" b="1">
                 <a:solidFill>
                   <a:srgbClr val="FFFFFF"/>
                 </a:solidFill>
                 <a:latin typeface="Apple SD Gothic Neo"/>
               </a:rPr>
-              <a:t>핵심 질문: strong judge LLM의 논문 메시지가 오픈소스 judge 실험으로 어디까지 이어지는가?</a:t>
+              <a:t>핵심 질문: 이 논문의 strong-judge 메시지가 내 오픈소스 judge 재현 실험에서도 어디까지 유지되는가?</a:t>
             </a:r>
           </a:p>
         </p:txBody>
@@ -6429,7 +6430,7 @@
         </p:spPr>
         <p:txBody>
           <a:bodyPr wrap="square" lIns="0" rIns="0" tIns="0" bIns="0" anchor="t">
-            <a:spAutoFit/>
+            <a:normAutofit/>
           </a:bodyPr>
           <a:lstStyle/>
           <a:p>
@@ -6441,7 +6442,7 @@
                 </a:solidFill>
                 <a:latin typeface="Apple SD Gothic Neo"/>
               </a:rPr>
-              <a:t>박승현 | CLINK Lab | 논문 리뷰 + 내 연구</a:t>
+              <a:t>박승현 | CLINK Lab | paper study + my reproduction</a:t>
             </a:r>
           </a:p>
         </p:txBody>
@@ -6579,7 +6580,7 @@
         </p:spPr>
         <p:txBody>
           <a:bodyPr wrap="square" lIns="0" rIns="0" tIns="0" bIns="0" anchor="t">
-            <a:spAutoFit/>
+            <a:normAutofit/>
           </a:bodyPr>
           <a:lstStyle/>
           <a:p>
@@ -6617,7 +6618,7 @@
         </p:spPr>
         <p:txBody>
           <a:bodyPr wrap="square" lIns="0" rIns="0" tIns="0" bIns="0" anchor="t">
-            <a:spAutoFit/>
+            <a:normAutofit/>
           </a:bodyPr>
           <a:lstStyle/>
           <a:p>
@@ -6655,13 +6656,13 @@
         </p:spPr>
         <p:txBody>
           <a:bodyPr wrap="square" lIns="0" rIns="0" tIns="0" bIns="0" anchor="t">
-            <a:spAutoFit/>
+            <a:normAutofit/>
           </a:bodyPr>
           <a:lstStyle/>
           <a:p>
             <a:pPr algn="l"/>
             <a:r>
-              <a:rPr sz="3000" b="1">
+              <a:rPr sz="2800" b="1">
                 <a:solidFill>
                   <a:srgbClr val="282C3A"/>
                 </a:solidFill>
@@ -6697,7 +6698,7 @@
         </p:spPr>
         <p:txBody>
           <a:bodyPr wrap="square" lIns="109728" rIns="109728" tIns="109728" bIns="109728" anchor="t">
-            <a:spAutoFit/>
+            <a:normAutofit/>
           </a:bodyPr>
           <a:lstStyle/>
           <a:p>
@@ -6709,7 +6710,7 @@
                 </a:solidFill>
                 <a:latin typeface="Apple SD Gothic Neo"/>
               </a:rPr>
-              <a:t>이제부터는 paper claim을 다시 읽는 것이 아니라, 그 claim을 내 judge 실험으로 어디까지 옮길 수 있었는지 보여드립니다.</a:t>
+              <a:t>이제부터는 내 연구입니다. 원 논문의 프로토콜을 오픈소스 judge 실험으로 어떻게 재현하고 어디까지 확장했는지 보여드립니다.</a:t>
             </a:r>
           </a:p>
         </p:txBody>
@@ -6735,7 +6736,7 @@
         </p:spPr>
         <p:txBody>
           <a:bodyPr wrap="square" lIns="0" rIns="0" tIns="0" bIns="0" anchor="t">
-            <a:spAutoFit/>
+            <a:normAutofit/>
           </a:bodyPr>
           <a:lstStyle/>
           <a:p>
@@ -6885,7 +6886,7 @@
         </p:spPr>
         <p:txBody>
           <a:bodyPr wrap="square" lIns="0" rIns="0" tIns="0" bIns="0" anchor="t">
-            <a:spAutoFit/>
+            <a:normAutofit/>
           </a:bodyPr>
           <a:lstStyle/>
           <a:p>
@@ -6927,7 +6928,7 @@
         </p:spPr>
         <p:txBody>
           <a:bodyPr wrap="square" lIns="9144" rIns="9144" tIns="9144" bIns="9144" anchor="ctr">
-            <a:spAutoFit/>
+            <a:normAutofit/>
           </a:bodyPr>
           <a:lstStyle/>
           <a:p>
@@ -6965,7 +6966,7 @@
         </p:spPr>
         <p:txBody>
           <a:bodyPr wrap="square" lIns="0" rIns="0" tIns="0" bIns="0" anchor="ctr">
-            <a:spAutoFit/>
+            <a:normAutofit/>
           </a:bodyPr>
           <a:lstStyle/>
           <a:p>
@@ -7046,7 +7047,7 @@
         </p:spPr>
         <p:txBody>
           <a:bodyPr wrap="square" lIns="0" rIns="0" tIns="0" bIns="0" anchor="t">
-            <a:spAutoFit/>
+            <a:normAutofit/>
           </a:bodyPr>
           <a:lstStyle/>
           <a:p>
@@ -7088,7 +7089,7 @@
         </p:spPr>
         <p:txBody>
           <a:bodyPr wrap="square" lIns="27432" rIns="27432" tIns="27432" bIns="27432" anchor="ctr">
-            <a:spAutoFit/>
+            <a:normAutofit/>
           </a:bodyPr>
           <a:lstStyle/>
           <a:p>
@@ -7130,7 +7131,7 @@
         </p:spPr>
         <p:txBody>
           <a:bodyPr wrap="square" lIns="64008" rIns="64008" tIns="64008" bIns="64008" anchor="ctr">
-            <a:spAutoFit/>
+            <a:normAutofit/>
           </a:bodyPr>
           <a:lstStyle/>
           <a:p>
@@ -7172,7 +7173,7 @@
         </p:spPr>
         <p:txBody>
           <a:bodyPr wrap="square" lIns="109728" rIns="109728" tIns="109728" bIns="109728" anchor="t">
-            <a:spAutoFit/>
+            <a:normAutofit/>
           </a:bodyPr>
           <a:lstStyle/>
           <a:p>
@@ -7210,7 +7211,7 @@
         </p:spPr>
         <p:txBody>
           <a:bodyPr wrap="square" lIns="0" rIns="0" tIns="0" bIns="0" anchor="t">
-            <a:spAutoFit/>
+            <a:normAutofit/>
           </a:bodyPr>
           <a:lstStyle/>
           <a:p>
@@ -7248,7 +7249,7 @@
         </p:spPr>
         <p:txBody>
           <a:bodyPr wrap="square" lIns="0" rIns="0" tIns="0" bIns="0" anchor="t">
-            <a:spAutoFit/>
+            <a:normAutofit/>
           </a:bodyPr>
           <a:lstStyle/>
           <a:p>
@@ -7290,7 +7291,7 @@
         </p:spPr>
         <p:txBody>
           <a:bodyPr wrap="square" lIns="109728" rIns="109728" tIns="109728" bIns="109728" anchor="t">
-            <a:spAutoFit/>
+            <a:normAutofit/>
           </a:bodyPr>
           <a:lstStyle/>
           <a:p>
@@ -7328,7 +7329,7 @@
         </p:spPr>
         <p:txBody>
           <a:bodyPr wrap="square" lIns="0" rIns="0" tIns="0" bIns="0" anchor="t">
-            <a:spAutoFit/>
+            <a:normAutofit/>
           </a:bodyPr>
           <a:lstStyle/>
           <a:p>
@@ -7366,7 +7367,7 @@
         </p:spPr>
         <p:txBody>
           <a:bodyPr wrap="square" lIns="0" rIns="0" tIns="0" bIns="0" anchor="t">
-            <a:spAutoFit/>
+            <a:normAutofit/>
           </a:bodyPr>
           <a:lstStyle/>
           <a:p>
@@ -7408,7 +7409,7 @@
         </p:spPr>
         <p:txBody>
           <a:bodyPr wrap="square" lIns="109728" rIns="109728" tIns="109728" bIns="109728" anchor="t">
-            <a:spAutoFit/>
+            <a:normAutofit/>
           </a:bodyPr>
           <a:lstStyle/>
           <a:p>
@@ -7446,7 +7447,7 @@
         </p:spPr>
         <p:txBody>
           <a:bodyPr wrap="square" lIns="0" rIns="0" tIns="0" bIns="0" anchor="t">
-            <a:spAutoFit/>
+            <a:normAutofit/>
           </a:bodyPr>
           <a:lstStyle/>
           <a:p>
@@ -7484,7 +7485,7 @@
         </p:spPr>
         <p:txBody>
           <a:bodyPr wrap="square" lIns="0" rIns="0" tIns="0" bIns="0" anchor="t">
-            <a:spAutoFit/>
+            <a:normAutofit/>
           </a:bodyPr>
           <a:lstStyle/>
           <a:p>
@@ -7526,7 +7527,7 @@
         </p:spPr>
         <p:txBody>
           <a:bodyPr wrap="square" lIns="109728" rIns="109728" tIns="109728" bIns="109728" anchor="t">
-            <a:spAutoFit/>
+            <a:normAutofit/>
           </a:bodyPr>
           <a:lstStyle/>
           <a:p>
@@ -7564,7 +7565,7 @@
         </p:spPr>
         <p:txBody>
           <a:bodyPr wrap="square" lIns="0" rIns="0" tIns="0" bIns="0" anchor="t">
-            <a:spAutoFit/>
+            <a:normAutofit/>
           </a:bodyPr>
           <a:lstStyle/>
           <a:p>
@@ -7602,7 +7603,7 @@
         </p:spPr>
         <p:txBody>
           <a:bodyPr wrap="square" lIns="0" rIns="0" tIns="0" bIns="0" anchor="t">
-            <a:spAutoFit/>
+            <a:normAutofit/>
           </a:bodyPr>
           <a:lstStyle/>
           <a:p>
@@ -7644,7 +7645,7 @@
         </p:spPr>
         <p:txBody>
           <a:bodyPr wrap="square" lIns="118872" rIns="118872" tIns="118872" bIns="118872" anchor="t">
-            <a:spAutoFit/>
+            <a:normAutofit/>
           </a:bodyPr>
           <a:lstStyle/>
           <a:p>
@@ -7804,7 +7805,7 @@
         </p:spPr>
         <p:txBody>
           <a:bodyPr wrap="square" lIns="0" rIns="0" tIns="0" bIns="0" anchor="t">
-            <a:spAutoFit/>
+            <a:normAutofit/>
           </a:bodyPr>
           <a:lstStyle/>
           <a:p>
@@ -7846,7 +7847,7 @@
         </p:spPr>
         <p:txBody>
           <a:bodyPr wrap="square" lIns="9144" rIns="9144" tIns="9144" bIns="9144" anchor="ctr">
-            <a:spAutoFit/>
+            <a:normAutofit/>
           </a:bodyPr>
           <a:lstStyle/>
           <a:p>
@@ -7884,7 +7885,7 @@
         </p:spPr>
         <p:txBody>
           <a:bodyPr wrap="square" lIns="0" rIns="0" tIns="0" bIns="0" anchor="ctr">
-            <a:spAutoFit/>
+            <a:normAutofit/>
           </a:bodyPr>
           <a:lstStyle/>
           <a:p>
@@ -7965,7 +7966,7 @@
         </p:spPr>
         <p:txBody>
           <a:bodyPr wrap="square" lIns="0" rIns="0" tIns="0" bIns="0" anchor="t">
-            <a:spAutoFit/>
+            <a:normAutofit/>
           </a:bodyPr>
           <a:lstStyle/>
           <a:p>
@@ -8007,7 +8008,7 @@
         </p:spPr>
         <p:txBody>
           <a:bodyPr wrap="square" lIns="27432" rIns="27432" tIns="27432" bIns="27432" anchor="ctr">
-            <a:spAutoFit/>
+            <a:normAutofit/>
           </a:bodyPr>
           <a:lstStyle/>
           <a:p>
@@ -8131,7 +8132,7 @@
         </p:spPr>
         <p:txBody>
           <a:bodyPr wrap="square" lIns="0" rIns="0" tIns="0" bIns="0" anchor="t">
-            <a:spAutoFit/>
+            <a:normAutofit/>
           </a:bodyPr>
           <a:lstStyle/>
           <a:p>
@@ -8169,7 +8170,7 @@
         </p:spPr>
         <p:txBody>
           <a:bodyPr wrap="square" lIns="0" rIns="0" tIns="0" bIns="0" anchor="t">
-            <a:spAutoFit/>
+            <a:normAutofit/>
           </a:bodyPr>
           <a:lstStyle/>
           <a:p>
@@ -8250,7 +8251,7 @@
         </p:spPr>
         <p:txBody>
           <a:bodyPr wrap="square" lIns="0" rIns="0" tIns="0" bIns="0" anchor="t">
-            <a:spAutoFit/>
+            <a:normAutofit/>
           </a:bodyPr>
           <a:lstStyle/>
           <a:p>
@@ -8288,7 +8289,7 @@
         </p:spPr>
         <p:txBody>
           <a:bodyPr wrap="square" lIns="0" rIns="0" tIns="0" bIns="0" anchor="t">
-            <a:spAutoFit/>
+            <a:normAutofit/>
           </a:bodyPr>
           <a:lstStyle/>
           <a:p>
@@ -8369,7 +8370,7 @@
         </p:spPr>
         <p:txBody>
           <a:bodyPr wrap="square" lIns="0" rIns="0" tIns="0" bIns="0" anchor="t">
-            <a:spAutoFit/>
+            <a:normAutofit/>
           </a:bodyPr>
           <a:lstStyle/>
           <a:p>
@@ -8407,7 +8408,7 @@
         </p:spPr>
         <p:txBody>
           <a:bodyPr wrap="square" lIns="0" rIns="0" tIns="0" bIns="0" anchor="t">
-            <a:spAutoFit/>
+            <a:normAutofit/>
           </a:bodyPr>
           <a:lstStyle/>
           <a:p>
@@ -8488,7 +8489,7 @@
         </p:spPr>
         <p:txBody>
           <a:bodyPr wrap="square" lIns="0" rIns="0" tIns="0" bIns="0" anchor="t">
-            <a:spAutoFit/>
+            <a:normAutofit/>
           </a:bodyPr>
           <a:lstStyle/>
           <a:p>
@@ -8526,7 +8527,7 @@
         </p:spPr>
         <p:txBody>
           <a:bodyPr wrap="square" lIns="0" rIns="0" tIns="0" bIns="0" anchor="t">
-            <a:spAutoFit/>
+            <a:normAutofit/>
           </a:bodyPr>
           <a:lstStyle/>
           <a:p>
@@ -8607,7 +8608,7 @@
         </p:spPr>
         <p:txBody>
           <a:bodyPr wrap="square" lIns="0" rIns="0" tIns="0" bIns="0" anchor="t">
-            <a:spAutoFit/>
+            <a:normAutofit/>
           </a:bodyPr>
           <a:lstStyle/>
           <a:p>
@@ -8645,7 +8646,7 @@
         </p:spPr>
         <p:txBody>
           <a:bodyPr wrap="square" lIns="0" rIns="0" tIns="0" bIns="0" anchor="t">
-            <a:spAutoFit/>
+            <a:normAutofit/>
           </a:bodyPr>
           <a:lstStyle/>
           <a:p>
@@ -8726,7 +8727,7 @@
         </p:spPr>
         <p:txBody>
           <a:bodyPr wrap="square" lIns="0" rIns="0" tIns="0" bIns="0" anchor="t">
-            <a:spAutoFit/>
+            <a:normAutofit/>
           </a:bodyPr>
           <a:lstStyle/>
           <a:p>
@@ -8764,7 +8765,7 @@
         </p:spPr>
         <p:txBody>
           <a:bodyPr wrap="square" lIns="0" rIns="0" tIns="0" bIns="0" anchor="t">
-            <a:spAutoFit/>
+            <a:normAutofit/>
           </a:bodyPr>
           <a:lstStyle/>
           <a:p>
@@ -8806,7 +8807,7 @@
         </p:spPr>
         <p:txBody>
           <a:bodyPr wrap="square" lIns="118872" rIns="118872" tIns="118872" bIns="118872" anchor="t">
-            <a:spAutoFit/>
+            <a:normAutofit/>
           </a:bodyPr>
           <a:lstStyle/>
           <a:p>
@@ -8924,7 +8925,7 @@
         </p:spPr>
         <p:txBody>
           <a:bodyPr wrap="square" lIns="64008" rIns="64008" tIns="64008" bIns="64008" anchor="ctr">
-            <a:spAutoFit/>
+            <a:normAutofit/>
           </a:bodyPr>
           <a:lstStyle/>
           <a:p>
@@ -9074,13 +9075,13 @@
         </p:spPr>
         <p:txBody>
           <a:bodyPr wrap="square" lIns="0" rIns="0" tIns="0" bIns="0" anchor="t">
-            <a:spAutoFit/>
+            <a:normAutofit/>
           </a:bodyPr>
           <a:lstStyle/>
           <a:p>
             <a:pPr algn="l"/>
             <a:r>
-              <a:rPr sz="2400" b="1">
+              <a:rPr sz="2100" b="1">
                 <a:solidFill>
                   <a:srgbClr val="282C3A"/>
                 </a:solidFill>
@@ -9116,7 +9117,7 @@
         </p:spPr>
         <p:txBody>
           <a:bodyPr wrap="square" lIns="9144" rIns="9144" tIns="9144" bIns="9144" anchor="ctr">
-            <a:spAutoFit/>
+            <a:normAutofit/>
           </a:bodyPr>
           <a:lstStyle/>
           <a:p>
@@ -9154,7 +9155,7 @@
         </p:spPr>
         <p:txBody>
           <a:bodyPr wrap="square" lIns="0" rIns="0" tIns="0" bIns="0" anchor="ctr">
-            <a:spAutoFit/>
+            <a:normAutofit/>
           </a:bodyPr>
           <a:lstStyle/>
           <a:p>
@@ -9235,7 +9236,7 @@
         </p:spPr>
         <p:txBody>
           <a:bodyPr wrap="square" lIns="0" rIns="0" tIns="0" bIns="0" anchor="t">
-            <a:spAutoFit/>
+            <a:normAutofit/>
           </a:bodyPr>
           <a:lstStyle/>
           <a:p>
@@ -9277,7 +9278,7 @@
         </p:spPr>
         <p:txBody>
           <a:bodyPr wrap="square" lIns="27432" rIns="27432" tIns="27432" bIns="27432" anchor="ctr">
-            <a:spAutoFit/>
+            <a:normAutofit/>
           </a:bodyPr>
           <a:lstStyle/>
           <a:p>
@@ -9319,7 +9320,7 @@
         </p:spPr>
         <p:txBody>
           <a:bodyPr wrap="square" lIns="109728" rIns="109728" tIns="109728" bIns="109728" anchor="t">
-            <a:spAutoFit/>
+            <a:normAutofit/>
           </a:bodyPr>
           <a:lstStyle/>
           <a:p>
@@ -9385,7 +9386,7 @@
         </p:spPr>
         <p:txBody>
           <a:bodyPr wrap="square" lIns="109728" rIns="109728" tIns="109728" bIns="109728" anchor="t">
-            <a:spAutoFit/>
+            <a:normAutofit/>
           </a:bodyPr>
           <a:lstStyle/>
           <a:p>
@@ -9447,7 +9448,7 @@
         </p:spPr>
         <p:txBody>
           <a:bodyPr wrap="square" lIns="64008" rIns="64008" tIns="64008" bIns="64008" anchor="t">
-            <a:spAutoFit/>
+            <a:normAutofit/>
           </a:bodyPr>
           <a:lstStyle/>
           <a:p>
@@ -9485,7 +9486,7 @@
         </p:spPr>
         <p:txBody>
           <a:bodyPr wrap="square" lIns="64008" rIns="64008" tIns="64008" bIns="64008" anchor="t">
-            <a:spAutoFit/>
+            <a:normAutofit/>
           </a:bodyPr>
           <a:lstStyle/>
           <a:p>
@@ -9527,7 +9528,7 @@
         </p:spPr>
         <p:txBody>
           <a:bodyPr wrap="square" lIns="118872" rIns="118872" tIns="118872" bIns="118872" anchor="t">
-            <a:spAutoFit/>
+            <a:normAutofit/>
           </a:bodyPr>
           <a:lstStyle/>
           <a:p>
@@ -9541,7 +9542,7 @@
               <a:spcAft>
                 <a:spcPts val="800"/>
               </a:spcAft>
-              <a:defRPr sz="1600">
+              <a:defRPr sz="1500">
                 <a:solidFill>
                   <a:srgbClr val="363A48"/>
                 </a:solidFill>
@@ -9563,7 +9564,7 @@
               <a:spcAft>
                 <a:spcPts val="800"/>
               </a:spcAft>
-              <a:defRPr sz="1600">
+              <a:defRPr sz="1500">
                 <a:solidFill>
                   <a:srgbClr val="363A48"/>
                 </a:solidFill>
@@ -9585,7 +9586,7 @@
               <a:spcAft>
                 <a:spcPts val="800"/>
               </a:spcAft>
-              <a:defRPr sz="1600">
+              <a:defRPr sz="1500">
                 <a:solidFill>
                   <a:srgbClr val="363A48"/>
                 </a:solidFill>
@@ -9607,7 +9608,7 @@
               <a:spcAft>
                 <a:spcPts val="800"/>
               </a:spcAft>
-              <a:defRPr sz="1600">
+              <a:defRPr sz="1500">
                 <a:solidFill>
                   <a:srgbClr val="363A48"/>
                 </a:solidFill>
@@ -9645,7 +9646,7 @@
         </p:spPr>
         <p:txBody>
           <a:bodyPr wrap="square" lIns="64008" rIns="64008" tIns="64008" bIns="64008" anchor="ctr">
-            <a:spAutoFit/>
+            <a:normAutofit/>
           </a:bodyPr>
           <a:lstStyle/>
           <a:p>
@@ -9795,13 +9796,13 @@
         </p:spPr>
         <p:txBody>
           <a:bodyPr wrap="square" lIns="0" rIns="0" tIns="0" bIns="0" anchor="t">
-            <a:spAutoFit/>
+            <a:normAutofit/>
           </a:bodyPr>
           <a:lstStyle/>
           <a:p>
             <a:pPr algn="l"/>
             <a:r>
-              <a:rPr sz="2400" b="1">
+              <a:rPr sz="2100" b="1">
                 <a:solidFill>
                   <a:srgbClr val="282C3A"/>
                 </a:solidFill>
@@ -9837,7 +9838,7 @@
         </p:spPr>
         <p:txBody>
           <a:bodyPr wrap="square" lIns="9144" rIns="9144" tIns="9144" bIns="9144" anchor="ctr">
-            <a:spAutoFit/>
+            <a:normAutofit/>
           </a:bodyPr>
           <a:lstStyle/>
           <a:p>
@@ -9875,7 +9876,7 @@
         </p:spPr>
         <p:txBody>
           <a:bodyPr wrap="square" lIns="0" rIns="0" tIns="0" bIns="0" anchor="ctr">
-            <a:spAutoFit/>
+            <a:normAutofit/>
           </a:bodyPr>
           <a:lstStyle/>
           <a:p>
@@ -9956,7 +9957,7 @@
         </p:spPr>
         <p:txBody>
           <a:bodyPr wrap="square" lIns="0" rIns="0" tIns="0" bIns="0" anchor="t">
-            <a:spAutoFit/>
+            <a:normAutofit/>
           </a:bodyPr>
           <a:lstStyle/>
           <a:p>
@@ -9998,7 +9999,7 @@
         </p:spPr>
         <p:txBody>
           <a:bodyPr wrap="square" lIns="27432" rIns="27432" tIns="27432" bIns="27432" anchor="ctr">
-            <a:spAutoFit/>
+            <a:normAutofit/>
           </a:bodyPr>
           <a:lstStyle/>
           <a:p>
@@ -10040,7 +10041,7 @@
         </p:spPr>
         <p:txBody>
           <a:bodyPr wrap="square" lIns="109728" rIns="109728" tIns="109728" bIns="109728" anchor="t">
-            <a:spAutoFit/>
+            <a:normAutofit/>
           </a:bodyPr>
           <a:lstStyle/>
           <a:p>
@@ -10106,7 +10107,7 @@
         </p:spPr>
         <p:txBody>
           <a:bodyPr wrap="square" lIns="109728" rIns="109728" tIns="109728" bIns="109728" anchor="t">
-            <a:spAutoFit/>
+            <a:normAutofit/>
           </a:bodyPr>
           <a:lstStyle/>
           <a:p>
@@ -10168,7 +10169,7 @@
         </p:spPr>
         <p:txBody>
           <a:bodyPr wrap="square" lIns="64008" rIns="64008" tIns="64008" bIns="64008" anchor="t">
-            <a:spAutoFit/>
+            <a:normAutofit/>
           </a:bodyPr>
           <a:lstStyle/>
           <a:p>
@@ -10206,7 +10207,7 @@
         </p:spPr>
         <p:txBody>
           <a:bodyPr wrap="square" lIns="64008" rIns="64008" tIns="64008" bIns="64008" anchor="t">
-            <a:spAutoFit/>
+            <a:normAutofit/>
           </a:bodyPr>
           <a:lstStyle/>
           <a:p>
@@ -10248,7 +10249,7 @@
         </p:spPr>
         <p:txBody>
           <a:bodyPr wrap="square" lIns="118872" rIns="118872" tIns="118872" bIns="118872" anchor="t">
-            <a:spAutoFit/>
+            <a:normAutofit/>
           </a:bodyPr>
           <a:lstStyle/>
           <a:p>
@@ -10344,7 +10345,7 @@
         </p:spPr>
         <p:txBody>
           <a:bodyPr wrap="square" lIns="54864" rIns="54864" tIns="54864" bIns="54864" anchor="t">
-            <a:spAutoFit/>
+            <a:normAutofit/>
           </a:bodyPr>
           <a:lstStyle/>
           <a:p>
@@ -10425,7 +10426,7 @@
         </p:spPr>
         <p:txBody>
           <a:bodyPr wrap="square" lIns="9144" rIns="9144" tIns="9144" bIns="9144" anchor="ctr">
-            <a:spAutoFit/>
+            <a:normAutofit/>
           </a:bodyPr>
           <a:lstStyle/>
           <a:p>
@@ -10463,7 +10464,7 @@
         </p:spPr>
         <p:txBody>
           <a:bodyPr wrap="square" lIns="9144" rIns="9144" tIns="9144" bIns="9144" anchor="t">
-            <a:spAutoFit/>
+            <a:normAutofit/>
           </a:bodyPr>
           <a:lstStyle/>
           <a:p>
@@ -10505,7 +10506,7 @@
         </p:spPr>
         <p:txBody>
           <a:bodyPr wrap="square" lIns="54864" rIns="54864" tIns="54864" bIns="54864" anchor="t">
-            <a:spAutoFit/>
+            <a:normAutofit/>
           </a:bodyPr>
           <a:lstStyle/>
           <a:p>
@@ -10586,7 +10587,7 @@
         </p:spPr>
         <p:txBody>
           <a:bodyPr wrap="square" lIns="9144" rIns="9144" tIns="9144" bIns="9144" anchor="ctr">
-            <a:spAutoFit/>
+            <a:normAutofit/>
           </a:bodyPr>
           <a:lstStyle/>
           <a:p>
@@ -10624,7 +10625,7 @@
         </p:spPr>
         <p:txBody>
           <a:bodyPr wrap="square" lIns="9144" rIns="9144" tIns="9144" bIns="9144" anchor="t">
-            <a:spAutoFit/>
+            <a:normAutofit/>
           </a:bodyPr>
           <a:lstStyle/>
           <a:p>
@@ -10666,7 +10667,7 @@
         </p:spPr>
         <p:txBody>
           <a:bodyPr wrap="square" lIns="54864" rIns="54864" tIns="54864" bIns="54864" anchor="t">
-            <a:spAutoFit/>
+            <a:normAutofit/>
           </a:bodyPr>
           <a:lstStyle/>
           <a:p>
@@ -10747,7 +10748,7 @@
         </p:spPr>
         <p:txBody>
           <a:bodyPr wrap="square" lIns="9144" rIns="9144" tIns="9144" bIns="9144" anchor="ctr">
-            <a:spAutoFit/>
+            <a:normAutofit/>
           </a:bodyPr>
           <a:lstStyle/>
           <a:p>
@@ -10785,7 +10786,7 @@
         </p:spPr>
         <p:txBody>
           <a:bodyPr wrap="square" lIns="9144" rIns="9144" tIns="9144" bIns="9144" anchor="t">
-            <a:spAutoFit/>
+            <a:normAutofit/>
           </a:bodyPr>
           <a:lstStyle/>
           <a:p>
@@ -10827,7 +10828,7 @@
         </p:spPr>
         <p:txBody>
           <a:bodyPr wrap="square" lIns="54864" rIns="54864" tIns="54864" bIns="54864" anchor="t">
-            <a:spAutoFit/>
+            <a:normAutofit/>
           </a:bodyPr>
           <a:lstStyle/>
           <a:p>
@@ -10908,7 +10909,7 @@
         </p:spPr>
         <p:txBody>
           <a:bodyPr wrap="square" lIns="9144" rIns="9144" tIns="9144" bIns="9144" anchor="ctr">
-            <a:spAutoFit/>
+            <a:normAutofit/>
           </a:bodyPr>
           <a:lstStyle/>
           <a:p>
@@ -10946,7 +10947,7 @@
         </p:spPr>
         <p:txBody>
           <a:bodyPr wrap="square" lIns="9144" rIns="9144" tIns="9144" bIns="9144" anchor="t">
-            <a:spAutoFit/>
+            <a:normAutofit/>
           </a:bodyPr>
           <a:lstStyle/>
           <a:p>
@@ -11096,13 +11097,13 @@
         </p:spPr>
         <p:txBody>
           <a:bodyPr wrap="square" lIns="0" rIns="0" tIns="0" bIns="0" anchor="t">
-            <a:spAutoFit/>
+            <a:normAutofit/>
           </a:bodyPr>
           <a:lstStyle/>
           <a:p>
             <a:pPr algn="l"/>
             <a:r>
-              <a:rPr sz="2400" b="1">
+              <a:rPr sz="2200" b="1">
                 <a:solidFill>
                   <a:srgbClr val="282C3A"/>
                 </a:solidFill>
@@ -11138,7 +11139,7 @@
         </p:spPr>
         <p:txBody>
           <a:bodyPr wrap="square" lIns="9144" rIns="9144" tIns="9144" bIns="9144" anchor="ctr">
-            <a:spAutoFit/>
+            <a:normAutofit/>
           </a:bodyPr>
           <a:lstStyle/>
           <a:p>
@@ -11176,7 +11177,7 @@
         </p:spPr>
         <p:txBody>
           <a:bodyPr wrap="square" lIns="0" rIns="0" tIns="0" bIns="0" anchor="ctr">
-            <a:spAutoFit/>
+            <a:normAutofit/>
           </a:bodyPr>
           <a:lstStyle/>
           <a:p>
@@ -11257,7 +11258,7 @@
         </p:spPr>
         <p:txBody>
           <a:bodyPr wrap="square" lIns="0" rIns="0" tIns="0" bIns="0" anchor="t">
-            <a:spAutoFit/>
+            <a:normAutofit/>
           </a:bodyPr>
           <a:lstStyle/>
           <a:p>
@@ -11299,7 +11300,7 @@
         </p:spPr>
         <p:txBody>
           <a:bodyPr wrap="square" lIns="27432" rIns="27432" tIns="27432" bIns="27432" anchor="ctr">
-            <a:spAutoFit/>
+            <a:normAutofit/>
           </a:bodyPr>
           <a:lstStyle/>
           <a:p>
@@ -11341,7 +11342,7 @@
         </p:spPr>
         <p:txBody>
           <a:bodyPr wrap="square" lIns="109728" rIns="109728" tIns="109728" bIns="109728" anchor="t">
-            <a:spAutoFit/>
+            <a:normAutofit/>
           </a:bodyPr>
           <a:lstStyle/>
           <a:p>
@@ -11407,7 +11408,7 @@
         </p:spPr>
         <p:txBody>
           <a:bodyPr wrap="square" lIns="109728" rIns="109728" tIns="109728" bIns="109728" anchor="t">
-            <a:spAutoFit/>
+            <a:normAutofit/>
           </a:bodyPr>
           <a:lstStyle/>
           <a:p>
@@ -11469,7 +11470,7 @@
         </p:spPr>
         <p:txBody>
           <a:bodyPr wrap="square" lIns="64008" rIns="64008" tIns="64008" bIns="64008" anchor="t">
-            <a:spAutoFit/>
+            <a:normAutofit/>
           </a:bodyPr>
           <a:lstStyle/>
           <a:p>
@@ -11507,7 +11508,7 @@
         </p:spPr>
         <p:txBody>
           <a:bodyPr wrap="square" lIns="64008" rIns="64008" tIns="64008" bIns="64008" anchor="t">
-            <a:spAutoFit/>
+            <a:normAutofit/>
           </a:bodyPr>
           <a:lstStyle/>
           <a:p>
@@ -11549,7 +11550,7 @@
         </p:spPr>
         <p:txBody>
           <a:bodyPr wrap="square" lIns="118872" rIns="118872" tIns="118872" bIns="118872" anchor="t">
-            <a:spAutoFit/>
+            <a:normAutofit/>
           </a:bodyPr>
           <a:lstStyle/>
           <a:p>
@@ -11563,7 +11564,7 @@
               <a:spcAft>
                 <a:spcPts val="800"/>
               </a:spcAft>
-              <a:defRPr sz="1600">
+              <a:defRPr sz="1500">
                 <a:solidFill>
                   <a:srgbClr val="363A48"/>
                 </a:solidFill>
@@ -11585,7 +11586,7 @@
               <a:spcAft>
                 <a:spcPts val="800"/>
               </a:spcAft>
-              <a:defRPr sz="1600">
+              <a:defRPr sz="1500">
                 <a:solidFill>
                   <a:srgbClr val="363A48"/>
                 </a:solidFill>
@@ -11607,7 +11608,7 @@
               <a:spcAft>
                 <a:spcPts val="800"/>
               </a:spcAft>
-              <a:defRPr sz="1600">
+              <a:defRPr sz="1500">
                 <a:solidFill>
                   <a:srgbClr val="363A48"/>
                 </a:solidFill>
@@ -11645,7 +11646,7 @@
         </p:spPr>
         <p:txBody>
           <a:bodyPr wrap="square" lIns="64008" rIns="64008" tIns="64008" bIns="64008" anchor="ctr">
-            <a:spAutoFit/>
+            <a:normAutofit/>
           </a:bodyPr>
           <a:lstStyle/>
           <a:p>
@@ -11795,13 +11796,13 @@
         </p:spPr>
         <p:txBody>
           <a:bodyPr wrap="square" lIns="0" rIns="0" tIns="0" bIns="0" anchor="t">
-            <a:spAutoFit/>
+            <a:normAutofit/>
           </a:bodyPr>
           <a:lstStyle/>
           <a:p>
             <a:pPr algn="l"/>
             <a:r>
-              <a:rPr sz="2400" b="1">
+              <a:rPr sz="2200" b="1">
                 <a:solidFill>
                   <a:srgbClr val="282C3A"/>
                 </a:solidFill>
@@ -11837,7 +11838,7 @@
         </p:spPr>
         <p:txBody>
           <a:bodyPr wrap="square" lIns="9144" rIns="9144" tIns="9144" bIns="9144" anchor="ctr">
-            <a:spAutoFit/>
+            <a:normAutofit/>
           </a:bodyPr>
           <a:lstStyle/>
           <a:p>
@@ -11875,7 +11876,7 @@
         </p:spPr>
         <p:txBody>
           <a:bodyPr wrap="square" lIns="0" rIns="0" tIns="0" bIns="0" anchor="ctr">
-            <a:spAutoFit/>
+            <a:normAutofit/>
           </a:bodyPr>
           <a:lstStyle/>
           <a:p>
@@ -11956,7 +11957,7 @@
         </p:spPr>
         <p:txBody>
           <a:bodyPr wrap="square" lIns="0" rIns="0" tIns="0" bIns="0" anchor="t">
-            <a:spAutoFit/>
+            <a:normAutofit/>
           </a:bodyPr>
           <a:lstStyle/>
           <a:p>
@@ -11998,7 +11999,7 @@
         </p:spPr>
         <p:txBody>
           <a:bodyPr wrap="square" lIns="27432" rIns="27432" tIns="27432" bIns="27432" anchor="ctr">
-            <a:spAutoFit/>
+            <a:normAutofit/>
           </a:bodyPr>
           <a:lstStyle/>
           <a:p>
@@ -12040,7 +12041,7 @@
         </p:spPr>
         <p:txBody>
           <a:bodyPr wrap="square" lIns="128016" rIns="128016" tIns="128016" bIns="128016" anchor="t">
-            <a:spAutoFit/>
+            <a:normAutofit/>
           </a:bodyPr>
           <a:lstStyle/>
           <a:p>
@@ -12054,7 +12055,7 @@
               <a:spcAft>
                 <a:spcPts val="800"/>
               </a:spcAft>
-              <a:defRPr sz="1800">
+              <a:defRPr sz="1500">
                 <a:solidFill>
                   <a:srgbClr val="363A48"/>
                 </a:solidFill>
@@ -12076,7 +12077,7 @@
               <a:spcAft>
                 <a:spcPts val="800"/>
               </a:spcAft>
-              <a:defRPr sz="1800">
+              <a:defRPr sz="1500">
                 <a:solidFill>
                   <a:srgbClr val="363A48"/>
                 </a:solidFill>
@@ -12098,7 +12099,7 @@
               <a:spcAft>
                 <a:spcPts val="800"/>
               </a:spcAft>
-              <a:defRPr sz="1800">
+              <a:defRPr sz="1500">
                 <a:solidFill>
                   <a:srgbClr val="363A48"/>
                 </a:solidFill>
@@ -12120,7 +12121,7 @@
               <a:spcAft>
                 <a:spcPts val="800"/>
               </a:spcAft>
-              <a:defRPr sz="1800">
+              <a:defRPr sz="1500">
                 <a:solidFill>
                   <a:srgbClr val="363A48"/>
                 </a:solidFill>
@@ -12154,7 +12155,7 @@
         </p:spPr>
         <p:txBody>
           <a:bodyPr wrap="square" lIns="64008" rIns="64008" tIns="64008" bIns="64008" anchor="t">
-            <a:spAutoFit/>
+            <a:normAutofit/>
           </a:bodyPr>
           <a:lstStyle/>
           <a:p>
@@ -12196,7 +12197,7 @@
         </p:spPr>
         <p:txBody>
           <a:bodyPr wrap="square" lIns="128016" rIns="128016" tIns="128016" bIns="128016" anchor="t">
-            <a:spAutoFit/>
+            <a:normAutofit/>
           </a:bodyPr>
           <a:lstStyle/>
           <a:p>
@@ -12234,7 +12235,7 @@
         </p:spPr>
         <p:txBody>
           <a:bodyPr wrap="square" lIns="0" rIns="0" tIns="0" bIns="0" anchor="t">
-            <a:spAutoFit/>
+            <a:normAutofit/>
           </a:bodyPr>
           <a:lstStyle/>
           <a:p>
@@ -12276,7 +12277,7 @@
         </p:spPr>
         <p:txBody>
           <a:bodyPr wrap="square" lIns="54864" rIns="54864" tIns="54864" bIns="54864" anchor="t">
-            <a:spAutoFit/>
+            <a:normAutofit/>
           </a:bodyPr>
           <a:lstStyle/>
           <a:p>
@@ -12357,7 +12358,7 @@
         </p:spPr>
         <p:txBody>
           <a:bodyPr wrap="square" lIns="9144" rIns="9144" tIns="9144" bIns="9144" anchor="ctr">
-            <a:spAutoFit/>
+            <a:normAutofit/>
           </a:bodyPr>
           <a:lstStyle/>
           <a:p>
@@ -12395,7 +12396,7 @@
         </p:spPr>
         <p:txBody>
           <a:bodyPr wrap="square" lIns="9144" rIns="9144" tIns="9144" bIns="9144" anchor="t">
-            <a:spAutoFit/>
+            <a:normAutofit/>
           </a:bodyPr>
           <a:lstStyle/>
           <a:p>
@@ -12437,7 +12438,7 @@
         </p:spPr>
         <p:txBody>
           <a:bodyPr wrap="square" lIns="54864" rIns="54864" tIns="54864" bIns="54864" anchor="t">
-            <a:spAutoFit/>
+            <a:normAutofit/>
           </a:bodyPr>
           <a:lstStyle/>
           <a:p>
@@ -12518,7 +12519,7 @@
         </p:spPr>
         <p:txBody>
           <a:bodyPr wrap="square" lIns="9144" rIns="9144" tIns="9144" bIns="9144" anchor="ctr">
-            <a:spAutoFit/>
+            <a:normAutofit/>
           </a:bodyPr>
           <a:lstStyle/>
           <a:p>
@@ -12556,7 +12557,7 @@
         </p:spPr>
         <p:txBody>
           <a:bodyPr wrap="square" lIns="9144" rIns="9144" tIns="9144" bIns="9144" anchor="t">
-            <a:spAutoFit/>
+            <a:normAutofit/>
           </a:bodyPr>
           <a:lstStyle/>
           <a:p>
@@ -12598,7 +12599,7 @@
         </p:spPr>
         <p:txBody>
           <a:bodyPr wrap="square" lIns="54864" rIns="54864" tIns="54864" bIns="54864" anchor="t">
-            <a:spAutoFit/>
+            <a:normAutofit/>
           </a:bodyPr>
           <a:lstStyle/>
           <a:p>
@@ -12679,7 +12680,7 @@
         </p:spPr>
         <p:txBody>
           <a:bodyPr wrap="square" lIns="9144" rIns="9144" tIns="9144" bIns="9144" anchor="ctr">
-            <a:spAutoFit/>
+            <a:normAutofit/>
           </a:bodyPr>
           <a:lstStyle/>
           <a:p>
@@ -12717,7 +12718,7 @@
         </p:spPr>
         <p:txBody>
           <a:bodyPr wrap="square" lIns="9144" rIns="9144" tIns="9144" bIns="9144" anchor="t">
-            <a:spAutoFit/>
+            <a:normAutofit/>
           </a:bodyPr>
           <a:lstStyle/>
           <a:p>
@@ -12759,7 +12760,7 @@
         </p:spPr>
         <p:txBody>
           <a:bodyPr wrap="square" lIns="54864" rIns="54864" tIns="54864" bIns="54864" anchor="t">
-            <a:spAutoFit/>
+            <a:normAutofit/>
           </a:bodyPr>
           <a:lstStyle/>
           <a:p>
@@ -12840,7 +12841,7 @@
         </p:spPr>
         <p:txBody>
           <a:bodyPr wrap="square" lIns="9144" rIns="9144" tIns="9144" bIns="9144" anchor="ctr">
-            <a:spAutoFit/>
+            <a:normAutofit/>
           </a:bodyPr>
           <a:lstStyle/>
           <a:p>
@@ -12878,7 +12879,7 @@
         </p:spPr>
         <p:txBody>
           <a:bodyPr wrap="square" lIns="9144" rIns="9144" tIns="9144" bIns="9144" anchor="t">
-            <a:spAutoFit/>
+            <a:normAutofit/>
           </a:bodyPr>
           <a:lstStyle/>
           <a:p>
@@ -13028,13 +13029,13 @@
         </p:spPr>
         <p:txBody>
           <a:bodyPr wrap="square" lIns="0" rIns="0" tIns="0" bIns="0" anchor="t">
-            <a:spAutoFit/>
+            <a:normAutofit/>
           </a:bodyPr>
           <a:lstStyle/>
           <a:p>
             <a:pPr algn="l"/>
             <a:r>
-              <a:rPr sz="2400" b="1">
+              <a:rPr sz="2200" b="1">
                 <a:solidFill>
                   <a:srgbClr val="282C3A"/>
                 </a:solidFill>
@@ -13070,7 +13071,7 @@
         </p:spPr>
         <p:txBody>
           <a:bodyPr wrap="square" lIns="9144" rIns="9144" tIns="9144" bIns="9144" anchor="ctr">
-            <a:spAutoFit/>
+            <a:normAutofit/>
           </a:bodyPr>
           <a:lstStyle/>
           <a:p>
@@ -13108,7 +13109,7 @@
         </p:spPr>
         <p:txBody>
           <a:bodyPr wrap="square" lIns="0" rIns="0" tIns="0" bIns="0" anchor="ctr">
-            <a:spAutoFit/>
+            <a:normAutofit/>
           </a:bodyPr>
           <a:lstStyle/>
           <a:p>
@@ -13189,7 +13190,7 @@
         </p:spPr>
         <p:txBody>
           <a:bodyPr wrap="square" lIns="0" rIns="0" tIns="0" bIns="0" anchor="t">
-            <a:spAutoFit/>
+            <a:normAutofit/>
           </a:bodyPr>
           <a:lstStyle/>
           <a:p>
@@ -13231,7 +13232,7 @@
         </p:spPr>
         <p:txBody>
           <a:bodyPr wrap="square" lIns="27432" rIns="27432" tIns="27432" bIns="27432" anchor="ctr">
-            <a:spAutoFit/>
+            <a:normAutofit/>
           </a:bodyPr>
           <a:lstStyle/>
           <a:p>
@@ -13273,7 +13274,7 @@
         </p:spPr>
         <p:txBody>
           <a:bodyPr wrap="square" lIns="109728" rIns="109728" tIns="109728" bIns="109728" anchor="t">
-            <a:spAutoFit/>
+            <a:normAutofit/>
           </a:bodyPr>
           <a:lstStyle/>
           <a:p>
@@ -13339,7 +13340,7 @@
         </p:spPr>
         <p:txBody>
           <a:bodyPr wrap="square" lIns="109728" rIns="109728" tIns="109728" bIns="109728" anchor="t">
-            <a:spAutoFit/>
+            <a:normAutofit/>
           </a:bodyPr>
           <a:lstStyle/>
           <a:p>
@@ -13401,7 +13402,7 @@
         </p:spPr>
         <p:txBody>
           <a:bodyPr wrap="square" lIns="64008" rIns="64008" tIns="64008" bIns="64008" anchor="t">
-            <a:spAutoFit/>
+            <a:normAutofit/>
           </a:bodyPr>
           <a:lstStyle/>
           <a:p>
@@ -13439,7 +13440,7 @@
         </p:spPr>
         <p:txBody>
           <a:bodyPr wrap="square" lIns="64008" rIns="64008" tIns="64008" bIns="64008" anchor="t">
-            <a:spAutoFit/>
+            <a:normAutofit/>
           </a:bodyPr>
           <a:lstStyle/>
           <a:p>
@@ -13481,7 +13482,7 @@
         </p:spPr>
         <p:txBody>
           <a:bodyPr wrap="square" lIns="118872" rIns="118872" tIns="118872" bIns="118872" anchor="t">
-            <a:spAutoFit/>
+            <a:normAutofit/>
           </a:bodyPr>
           <a:lstStyle/>
           <a:p>
@@ -13577,7 +13578,7 @@
         </p:spPr>
         <p:txBody>
           <a:bodyPr wrap="square" lIns="54864" rIns="54864" tIns="54864" bIns="54864" anchor="t">
-            <a:spAutoFit/>
+            <a:normAutofit/>
           </a:bodyPr>
           <a:lstStyle/>
           <a:p>
@@ -13658,7 +13659,7 @@
         </p:spPr>
         <p:txBody>
           <a:bodyPr wrap="square" lIns="9144" rIns="9144" tIns="9144" bIns="9144" anchor="ctr">
-            <a:spAutoFit/>
+            <a:normAutofit/>
           </a:bodyPr>
           <a:lstStyle/>
           <a:p>
@@ -13696,7 +13697,7 @@
         </p:spPr>
         <p:txBody>
           <a:bodyPr wrap="square" lIns="9144" rIns="9144" tIns="9144" bIns="9144" anchor="t">
-            <a:spAutoFit/>
+            <a:normAutofit/>
           </a:bodyPr>
           <a:lstStyle/>
           <a:p>
@@ -13738,7 +13739,7 @@
         </p:spPr>
         <p:txBody>
           <a:bodyPr wrap="square" lIns="54864" rIns="54864" tIns="54864" bIns="54864" anchor="t">
-            <a:spAutoFit/>
+            <a:normAutofit/>
           </a:bodyPr>
           <a:lstStyle/>
           <a:p>
@@ -13819,7 +13820,7 @@
         </p:spPr>
         <p:txBody>
           <a:bodyPr wrap="square" lIns="9144" rIns="9144" tIns="9144" bIns="9144" anchor="ctr">
-            <a:spAutoFit/>
+            <a:normAutofit/>
           </a:bodyPr>
           <a:lstStyle/>
           <a:p>
@@ -13857,7 +13858,7 @@
         </p:spPr>
         <p:txBody>
           <a:bodyPr wrap="square" lIns="9144" rIns="9144" tIns="9144" bIns="9144" anchor="t">
-            <a:spAutoFit/>
+            <a:normAutofit/>
           </a:bodyPr>
           <a:lstStyle/>
           <a:p>
@@ -13899,7 +13900,7 @@
         </p:spPr>
         <p:txBody>
           <a:bodyPr wrap="square" lIns="54864" rIns="54864" tIns="54864" bIns="54864" anchor="t">
-            <a:spAutoFit/>
+            <a:normAutofit/>
           </a:bodyPr>
           <a:lstStyle/>
           <a:p>
@@ -13980,7 +13981,7 @@
         </p:spPr>
         <p:txBody>
           <a:bodyPr wrap="square" lIns="9144" rIns="9144" tIns="9144" bIns="9144" anchor="ctr">
-            <a:spAutoFit/>
+            <a:normAutofit/>
           </a:bodyPr>
           <a:lstStyle/>
           <a:p>
@@ -14018,7 +14019,7 @@
         </p:spPr>
         <p:txBody>
           <a:bodyPr wrap="square" lIns="9144" rIns="9144" tIns="9144" bIns="9144" anchor="t">
-            <a:spAutoFit/>
+            <a:normAutofit/>
           </a:bodyPr>
           <a:lstStyle/>
           <a:p>
@@ -14060,7 +14061,7 @@
         </p:spPr>
         <p:txBody>
           <a:bodyPr wrap="square" lIns="54864" rIns="54864" tIns="54864" bIns="54864" anchor="t">
-            <a:spAutoFit/>
+            <a:normAutofit/>
           </a:bodyPr>
           <a:lstStyle/>
           <a:p>
@@ -14141,7 +14142,7 @@
         </p:spPr>
         <p:txBody>
           <a:bodyPr wrap="square" lIns="9144" rIns="9144" tIns="9144" bIns="9144" anchor="ctr">
-            <a:spAutoFit/>
+            <a:normAutofit/>
           </a:bodyPr>
           <a:lstStyle/>
           <a:p>
@@ -14179,7 +14180,7 @@
         </p:spPr>
         <p:txBody>
           <a:bodyPr wrap="square" lIns="9144" rIns="9144" tIns="9144" bIns="9144" anchor="t">
-            <a:spAutoFit/>
+            <a:normAutofit/>
           </a:bodyPr>
           <a:lstStyle/>
           <a:p>
@@ -14329,13 +14330,13 @@
         </p:spPr>
         <p:txBody>
           <a:bodyPr wrap="square" lIns="0" rIns="0" tIns="0" bIns="0" anchor="t">
-            <a:spAutoFit/>
+            <a:normAutofit/>
           </a:bodyPr>
           <a:lstStyle/>
           <a:p>
             <a:pPr algn="l"/>
             <a:r>
-              <a:rPr sz="2400" b="1">
+              <a:rPr sz="2100" b="1">
                 <a:solidFill>
                   <a:srgbClr val="282C3A"/>
                 </a:solidFill>
@@ -14371,7 +14372,7 @@
         </p:spPr>
         <p:txBody>
           <a:bodyPr wrap="square" lIns="9144" rIns="9144" tIns="9144" bIns="9144" anchor="ctr">
-            <a:spAutoFit/>
+            <a:normAutofit/>
           </a:bodyPr>
           <a:lstStyle/>
           <a:p>
@@ -14409,7 +14410,7 @@
         </p:spPr>
         <p:txBody>
           <a:bodyPr wrap="square" lIns="0" rIns="0" tIns="0" bIns="0" anchor="ctr">
-            <a:spAutoFit/>
+            <a:normAutofit/>
           </a:bodyPr>
           <a:lstStyle/>
           <a:p>
@@ -14490,7 +14491,7 @@
         </p:spPr>
         <p:txBody>
           <a:bodyPr wrap="square" lIns="0" rIns="0" tIns="0" bIns="0" anchor="t">
-            <a:spAutoFit/>
+            <a:normAutofit/>
           </a:bodyPr>
           <a:lstStyle/>
           <a:p>
@@ -14532,7 +14533,7 @@
         </p:spPr>
         <p:txBody>
           <a:bodyPr wrap="square" lIns="27432" rIns="27432" tIns="27432" bIns="27432" anchor="ctr">
-            <a:spAutoFit/>
+            <a:normAutofit/>
           </a:bodyPr>
           <a:lstStyle/>
           <a:p>
@@ -14574,7 +14575,7 @@
         </p:spPr>
         <p:txBody>
           <a:bodyPr wrap="square" lIns="109728" rIns="109728" tIns="109728" bIns="109728" anchor="t">
-            <a:spAutoFit/>
+            <a:normAutofit/>
           </a:bodyPr>
           <a:lstStyle/>
           <a:p>
@@ -14640,7 +14641,7 @@
         </p:spPr>
         <p:txBody>
           <a:bodyPr wrap="square" lIns="109728" rIns="109728" tIns="109728" bIns="109728" anchor="t">
-            <a:spAutoFit/>
+            <a:normAutofit/>
           </a:bodyPr>
           <a:lstStyle/>
           <a:p>
@@ -14702,7 +14703,7 @@
         </p:spPr>
         <p:txBody>
           <a:bodyPr wrap="square" lIns="64008" rIns="64008" tIns="64008" bIns="64008" anchor="t">
-            <a:spAutoFit/>
+            <a:normAutofit/>
           </a:bodyPr>
           <a:lstStyle/>
           <a:p>
@@ -14740,7 +14741,7 @@
         </p:spPr>
         <p:txBody>
           <a:bodyPr wrap="square" lIns="64008" rIns="64008" tIns="64008" bIns="64008" anchor="t">
-            <a:spAutoFit/>
+            <a:normAutofit/>
           </a:bodyPr>
           <a:lstStyle/>
           <a:p>
@@ -14782,7 +14783,7 @@
         </p:spPr>
         <p:txBody>
           <a:bodyPr wrap="square" lIns="118872" rIns="118872" tIns="118872" bIns="118872" anchor="t">
-            <a:spAutoFit/>
+            <a:normAutofit/>
           </a:bodyPr>
           <a:lstStyle/>
           <a:p>
@@ -14796,7 +14797,7 @@
               <a:spcAft>
                 <a:spcPts val="800"/>
               </a:spcAft>
-              <a:defRPr sz="1600">
+              <a:defRPr sz="1500">
                 <a:solidFill>
                   <a:srgbClr val="363A48"/>
                 </a:solidFill>
@@ -14818,7 +14819,7 @@
               <a:spcAft>
                 <a:spcPts val="800"/>
               </a:spcAft>
-              <a:defRPr sz="1600">
+              <a:defRPr sz="1500">
                 <a:solidFill>
                   <a:srgbClr val="363A48"/>
                 </a:solidFill>
@@ -14840,7 +14841,7 @@
               <a:spcAft>
                 <a:spcPts val="800"/>
               </a:spcAft>
-              <a:defRPr sz="1600">
+              <a:defRPr sz="1500">
                 <a:solidFill>
                   <a:srgbClr val="363A48"/>
                 </a:solidFill>
@@ -14878,7 +14879,7 @@
         </p:spPr>
         <p:txBody>
           <a:bodyPr wrap="square" lIns="54864" rIns="54864" tIns="54864" bIns="54864" anchor="t">
-            <a:spAutoFit/>
+            <a:normAutofit/>
           </a:bodyPr>
           <a:lstStyle/>
           <a:p>
@@ -14959,7 +14960,7 @@
         </p:spPr>
         <p:txBody>
           <a:bodyPr wrap="square" lIns="9144" rIns="9144" tIns="9144" bIns="9144" anchor="ctr">
-            <a:spAutoFit/>
+            <a:normAutofit/>
           </a:bodyPr>
           <a:lstStyle/>
           <a:p>
@@ -14997,7 +14998,7 @@
         </p:spPr>
         <p:txBody>
           <a:bodyPr wrap="square" lIns="9144" rIns="9144" tIns="9144" bIns="9144" anchor="t">
-            <a:spAutoFit/>
+            <a:normAutofit/>
           </a:bodyPr>
           <a:lstStyle/>
           <a:p>
@@ -15039,7 +15040,7 @@
         </p:spPr>
         <p:txBody>
           <a:bodyPr wrap="square" lIns="54864" rIns="54864" tIns="54864" bIns="54864" anchor="t">
-            <a:spAutoFit/>
+            <a:normAutofit/>
           </a:bodyPr>
           <a:lstStyle/>
           <a:p>
@@ -15120,7 +15121,7 @@
         </p:spPr>
         <p:txBody>
           <a:bodyPr wrap="square" lIns="9144" rIns="9144" tIns="9144" bIns="9144" anchor="ctr">
-            <a:spAutoFit/>
+            <a:normAutofit/>
           </a:bodyPr>
           <a:lstStyle/>
           <a:p>
@@ -15158,7 +15159,7 @@
         </p:spPr>
         <p:txBody>
           <a:bodyPr wrap="square" lIns="9144" rIns="9144" tIns="9144" bIns="9144" anchor="t">
-            <a:spAutoFit/>
+            <a:normAutofit/>
           </a:bodyPr>
           <a:lstStyle/>
           <a:p>
@@ -15200,7 +15201,7 @@
         </p:spPr>
         <p:txBody>
           <a:bodyPr wrap="square" lIns="54864" rIns="54864" tIns="54864" bIns="54864" anchor="t">
-            <a:spAutoFit/>
+            <a:normAutofit/>
           </a:bodyPr>
           <a:lstStyle/>
           <a:p>
@@ -15281,7 +15282,7 @@
         </p:spPr>
         <p:txBody>
           <a:bodyPr wrap="square" lIns="9144" rIns="9144" tIns="9144" bIns="9144" anchor="ctr">
-            <a:spAutoFit/>
+            <a:normAutofit/>
           </a:bodyPr>
           <a:lstStyle/>
           <a:p>
@@ -15319,7 +15320,7 @@
         </p:spPr>
         <p:txBody>
           <a:bodyPr wrap="square" lIns="9144" rIns="9144" tIns="9144" bIns="9144" anchor="t">
-            <a:spAutoFit/>
+            <a:normAutofit/>
           </a:bodyPr>
           <a:lstStyle/>
           <a:p>
@@ -15361,7 +15362,7 @@
         </p:spPr>
         <p:txBody>
           <a:bodyPr wrap="square" lIns="54864" rIns="54864" tIns="54864" bIns="54864" anchor="t">
-            <a:spAutoFit/>
+            <a:normAutofit/>
           </a:bodyPr>
           <a:lstStyle/>
           <a:p>
@@ -15442,7 +15443,7 @@
         </p:spPr>
         <p:txBody>
           <a:bodyPr wrap="square" lIns="9144" rIns="9144" tIns="9144" bIns="9144" anchor="ctr">
-            <a:spAutoFit/>
+            <a:normAutofit/>
           </a:bodyPr>
           <a:lstStyle/>
           <a:p>
@@ -15480,7 +15481,7 @@
         </p:spPr>
         <p:txBody>
           <a:bodyPr wrap="square" lIns="9144" rIns="9144" tIns="9144" bIns="9144" anchor="t">
-            <a:spAutoFit/>
+            <a:normAutofit/>
           </a:bodyPr>
           <a:lstStyle/>
           <a:p>
@@ -15630,7 +15631,7 @@
         </p:spPr>
         <p:txBody>
           <a:bodyPr wrap="square" lIns="0" rIns="0" tIns="0" bIns="0" anchor="t">
-            <a:spAutoFit/>
+            <a:normAutofit/>
           </a:bodyPr>
           <a:lstStyle/>
           <a:p>
@@ -15672,7 +15673,7 @@
         </p:spPr>
         <p:txBody>
           <a:bodyPr wrap="square" lIns="9144" rIns="9144" tIns="9144" bIns="9144" anchor="ctr">
-            <a:spAutoFit/>
+            <a:normAutofit/>
           </a:bodyPr>
           <a:lstStyle/>
           <a:p>
@@ -15710,7 +15711,7 @@
         </p:spPr>
         <p:txBody>
           <a:bodyPr wrap="square" lIns="0" rIns="0" tIns="0" bIns="0" anchor="ctr">
-            <a:spAutoFit/>
+            <a:normAutofit/>
           </a:bodyPr>
           <a:lstStyle/>
           <a:p>
@@ -15791,7 +15792,7 @@
         </p:spPr>
         <p:txBody>
           <a:bodyPr wrap="square" lIns="0" rIns="0" tIns="0" bIns="0" anchor="t">
-            <a:spAutoFit/>
+            <a:normAutofit/>
           </a:bodyPr>
           <a:lstStyle/>
           <a:p>
@@ -15833,7 +15834,7 @@
         </p:spPr>
         <p:txBody>
           <a:bodyPr wrap="square" lIns="27432" rIns="27432" tIns="27432" bIns="27432" anchor="ctr">
-            <a:spAutoFit/>
+            <a:normAutofit/>
           </a:bodyPr>
           <a:lstStyle/>
           <a:p>
@@ -15875,7 +15876,7 @@
         </p:spPr>
         <p:txBody>
           <a:bodyPr wrap="square" lIns="64008" rIns="64008" tIns="64008" bIns="64008" anchor="ctr">
-            <a:spAutoFit/>
+            <a:normAutofit/>
           </a:bodyPr>
           <a:lstStyle/>
           <a:p>
@@ -15917,7 +15918,7 @@
         </p:spPr>
         <p:txBody>
           <a:bodyPr wrap="square" lIns="109728" rIns="109728" tIns="109728" bIns="109728" anchor="t">
-            <a:spAutoFit/>
+            <a:normAutofit/>
           </a:bodyPr>
           <a:lstStyle/>
           <a:p>
@@ -15955,7 +15956,7 @@
         </p:spPr>
         <p:txBody>
           <a:bodyPr wrap="square" lIns="0" rIns="0" tIns="0" bIns="0" anchor="t">
-            <a:spAutoFit/>
+            <a:normAutofit/>
           </a:bodyPr>
           <a:lstStyle/>
           <a:p>
@@ -15993,7 +15994,7 @@
         </p:spPr>
         <p:txBody>
           <a:bodyPr wrap="square" lIns="0" rIns="0" tIns="0" bIns="0" anchor="t">
-            <a:spAutoFit/>
+            <a:normAutofit/>
           </a:bodyPr>
           <a:lstStyle/>
           <a:p>
@@ -16035,7 +16036,7 @@
         </p:spPr>
         <p:txBody>
           <a:bodyPr wrap="square" lIns="109728" rIns="109728" tIns="109728" bIns="109728" anchor="t">
-            <a:spAutoFit/>
+            <a:normAutofit/>
           </a:bodyPr>
           <a:lstStyle/>
           <a:p>
@@ -16073,7 +16074,7 @@
         </p:spPr>
         <p:txBody>
           <a:bodyPr wrap="square" lIns="0" rIns="0" tIns="0" bIns="0" anchor="t">
-            <a:spAutoFit/>
+            <a:normAutofit/>
           </a:bodyPr>
           <a:lstStyle/>
           <a:p>
@@ -16111,7 +16112,7 @@
         </p:spPr>
         <p:txBody>
           <a:bodyPr wrap="square" lIns="0" rIns="0" tIns="0" bIns="0" anchor="t">
-            <a:spAutoFit/>
+            <a:normAutofit/>
           </a:bodyPr>
           <a:lstStyle/>
           <a:p>
@@ -16153,7 +16154,7 @@
         </p:spPr>
         <p:txBody>
           <a:bodyPr wrap="square" lIns="109728" rIns="109728" tIns="109728" bIns="109728" anchor="t">
-            <a:spAutoFit/>
+            <a:normAutofit/>
           </a:bodyPr>
           <a:lstStyle/>
           <a:p>
@@ -16191,7 +16192,7 @@
         </p:spPr>
         <p:txBody>
           <a:bodyPr wrap="square" lIns="0" rIns="0" tIns="0" bIns="0" anchor="t">
-            <a:spAutoFit/>
+            <a:normAutofit/>
           </a:bodyPr>
           <a:lstStyle/>
           <a:p>
@@ -16229,7 +16230,7 @@
         </p:spPr>
         <p:txBody>
           <a:bodyPr wrap="square" lIns="0" rIns="0" tIns="0" bIns="0" anchor="t">
-            <a:spAutoFit/>
+            <a:normAutofit/>
           </a:bodyPr>
           <a:lstStyle/>
           <a:p>
@@ -16271,7 +16272,7 @@
         </p:spPr>
         <p:txBody>
           <a:bodyPr wrap="square" lIns="109728" rIns="109728" tIns="109728" bIns="109728" anchor="t">
-            <a:spAutoFit/>
+            <a:normAutofit/>
           </a:bodyPr>
           <a:lstStyle/>
           <a:p>
@@ -16309,7 +16310,7 @@
         </p:spPr>
         <p:txBody>
           <a:bodyPr wrap="square" lIns="0" rIns="0" tIns="0" bIns="0" anchor="t">
-            <a:spAutoFit/>
+            <a:normAutofit/>
           </a:bodyPr>
           <a:lstStyle/>
           <a:p>
@@ -16347,7 +16348,7 @@
         </p:spPr>
         <p:txBody>
           <a:bodyPr wrap="square" lIns="0" rIns="0" tIns="0" bIns="0" anchor="t">
-            <a:spAutoFit/>
+            <a:normAutofit/>
           </a:bodyPr>
           <a:lstStyle/>
           <a:p>
@@ -16389,7 +16390,7 @@
         </p:spPr>
         <p:txBody>
           <a:bodyPr wrap="square" lIns="118872" rIns="118872" tIns="118872" bIns="118872" anchor="t">
-            <a:spAutoFit/>
+            <a:normAutofit/>
           </a:bodyPr>
           <a:lstStyle/>
           <a:p>
@@ -16549,13 +16550,13 @@
         </p:spPr>
         <p:txBody>
           <a:bodyPr wrap="square" lIns="0" rIns="0" tIns="0" bIns="0" anchor="t">
-            <a:spAutoFit/>
+            <a:normAutofit/>
           </a:bodyPr>
           <a:lstStyle/>
           <a:p>
             <a:pPr algn="l"/>
             <a:r>
-              <a:rPr sz="2400" b="1">
+              <a:rPr sz="2200" b="1">
                 <a:solidFill>
                   <a:srgbClr val="282C3A"/>
                 </a:solidFill>
@@ -16591,7 +16592,7 @@
         </p:spPr>
         <p:txBody>
           <a:bodyPr wrap="square" lIns="9144" rIns="9144" tIns="9144" bIns="9144" anchor="ctr">
-            <a:spAutoFit/>
+            <a:normAutofit/>
           </a:bodyPr>
           <a:lstStyle/>
           <a:p>
@@ -16629,7 +16630,7 @@
         </p:spPr>
         <p:txBody>
           <a:bodyPr wrap="square" lIns="0" rIns="0" tIns="0" bIns="0" anchor="ctr">
-            <a:spAutoFit/>
+            <a:normAutofit/>
           </a:bodyPr>
           <a:lstStyle/>
           <a:p>
@@ -16710,7 +16711,7 @@
         </p:spPr>
         <p:txBody>
           <a:bodyPr wrap="square" lIns="0" rIns="0" tIns="0" bIns="0" anchor="t">
-            <a:spAutoFit/>
+            <a:normAutofit/>
           </a:bodyPr>
           <a:lstStyle/>
           <a:p>
@@ -16752,7 +16753,7 @@
         </p:spPr>
         <p:txBody>
           <a:bodyPr wrap="square" lIns="27432" rIns="27432" tIns="27432" bIns="27432" anchor="ctr">
-            <a:spAutoFit/>
+            <a:normAutofit/>
           </a:bodyPr>
           <a:lstStyle/>
           <a:p>
@@ -16794,7 +16795,7 @@
         </p:spPr>
         <p:txBody>
           <a:bodyPr wrap="square" lIns="64008" rIns="64008" tIns="64008" bIns="64008" anchor="ctr">
-            <a:spAutoFit/>
+            <a:normAutofit/>
           </a:bodyPr>
           <a:lstStyle/>
           <a:p>
@@ -16836,7 +16837,7 @@
         </p:spPr>
         <p:txBody>
           <a:bodyPr wrap="square" lIns="109728" rIns="109728" tIns="109728" bIns="109728" anchor="t">
-            <a:spAutoFit/>
+            <a:normAutofit/>
           </a:bodyPr>
           <a:lstStyle/>
           <a:p>
@@ -16874,7 +16875,7 @@
         </p:spPr>
         <p:txBody>
           <a:bodyPr wrap="square" lIns="0" rIns="0" tIns="0" bIns="0" anchor="t">
-            <a:spAutoFit/>
+            <a:normAutofit/>
           </a:bodyPr>
           <a:lstStyle/>
           <a:p>
@@ -16912,7 +16913,7 @@
         </p:spPr>
         <p:txBody>
           <a:bodyPr wrap="square" lIns="0" rIns="0" tIns="0" bIns="0" anchor="t">
-            <a:spAutoFit/>
+            <a:normAutofit/>
           </a:bodyPr>
           <a:lstStyle/>
           <a:p>
@@ -16954,7 +16955,7 @@
         </p:spPr>
         <p:txBody>
           <a:bodyPr wrap="square" lIns="109728" rIns="109728" tIns="109728" bIns="109728" anchor="t">
-            <a:spAutoFit/>
+            <a:normAutofit/>
           </a:bodyPr>
           <a:lstStyle/>
           <a:p>
@@ -16992,7 +16993,7 @@
         </p:spPr>
         <p:txBody>
           <a:bodyPr wrap="square" lIns="0" rIns="0" tIns="0" bIns="0" anchor="t">
-            <a:spAutoFit/>
+            <a:normAutofit/>
           </a:bodyPr>
           <a:lstStyle/>
           <a:p>
@@ -17030,7 +17031,7 @@
         </p:spPr>
         <p:txBody>
           <a:bodyPr wrap="square" lIns="0" rIns="0" tIns="0" bIns="0" anchor="t">
-            <a:spAutoFit/>
+            <a:normAutofit/>
           </a:bodyPr>
           <a:lstStyle/>
           <a:p>
@@ -17072,7 +17073,7 @@
         </p:spPr>
         <p:txBody>
           <a:bodyPr wrap="square" lIns="109728" rIns="109728" tIns="109728" bIns="109728" anchor="t">
-            <a:spAutoFit/>
+            <a:normAutofit/>
           </a:bodyPr>
           <a:lstStyle/>
           <a:p>
@@ -17110,7 +17111,7 @@
         </p:spPr>
         <p:txBody>
           <a:bodyPr wrap="square" lIns="0" rIns="0" tIns="0" bIns="0" anchor="t">
-            <a:spAutoFit/>
+            <a:normAutofit/>
           </a:bodyPr>
           <a:lstStyle/>
           <a:p>
@@ -17148,7 +17149,7 @@
         </p:spPr>
         <p:txBody>
           <a:bodyPr wrap="square" lIns="0" rIns="0" tIns="0" bIns="0" anchor="t">
-            <a:spAutoFit/>
+            <a:normAutofit/>
           </a:bodyPr>
           <a:lstStyle/>
           <a:p>
@@ -17298,7 +17299,7 @@
         </p:spPr>
         <p:txBody>
           <a:bodyPr wrap="square" lIns="0" rIns="0" tIns="0" bIns="0" anchor="t">
-            <a:spAutoFit/>
+            <a:normAutofit/>
           </a:bodyPr>
           <a:lstStyle/>
           <a:p>
@@ -17340,7 +17341,7 @@
         </p:spPr>
         <p:txBody>
           <a:bodyPr wrap="square" lIns="9144" rIns="9144" tIns="9144" bIns="9144" anchor="ctr">
-            <a:spAutoFit/>
+            <a:normAutofit/>
           </a:bodyPr>
           <a:lstStyle/>
           <a:p>
@@ -17378,7 +17379,7 @@
         </p:spPr>
         <p:txBody>
           <a:bodyPr wrap="square" lIns="0" rIns="0" tIns="0" bIns="0" anchor="ctr">
-            <a:spAutoFit/>
+            <a:normAutofit/>
           </a:bodyPr>
           <a:lstStyle/>
           <a:p>
@@ -17459,7 +17460,7 @@
         </p:spPr>
         <p:txBody>
           <a:bodyPr wrap="square" lIns="0" rIns="0" tIns="0" bIns="0" anchor="t">
-            <a:spAutoFit/>
+            <a:normAutofit/>
           </a:bodyPr>
           <a:lstStyle/>
           <a:p>
@@ -17501,7 +17502,7 @@
         </p:spPr>
         <p:txBody>
           <a:bodyPr wrap="square" lIns="27432" rIns="27432" tIns="27432" bIns="27432" anchor="ctr">
-            <a:spAutoFit/>
+            <a:normAutofit/>
           </a:bodyPr>
           <a:lstStyle/>
           <a:p>
@@ -17543,7 +17544,7 @@
         </p:spPr>
         <p:txBody>
           <a:bodyPr wrap="square" lIns="128016" rIns="128016" tIns="128016" bIns="128016" anchor="t">
-            <a:spAutoFit/>
+            <a:normAutofit/>
           </a:bodyPr>
           <a:lstStyle/>
           <a:p>
@@ -17557,7 +17558,7 @@
               <a:spcAft>
                 <a:spcPts val="800"/>
               </a:spcAft>
-              <a:defRPr sz="1800">
+              <a:defRPr sz="1600">
                 <a:solidFill>
                   <a:srgbClr val="363A48"/>
                 </a:solidFill>
@@ -17579,7 +17580,7 @@
               <a:spcAft>
                 <a:spcPts val="800"/>
               </a:spcAft>
-              <a:defRPr sz="1800">
+              <a:defRPr sz="1600">
                 <a:solidFill>
                   <a:srgbClr val="363A48"/>
                 </a:solidFill>
@@ -17601,7 +17602,7 @@
               <a:spcAft>
                 <a:spcPts val="800"/>
               </a:spcAft>
-              <a:defRPr sz="1800">
+              <a:defRPr sz="1600">
                 <a:solidFill>
                   <a:srgbClr val="363A48"/>
                 </a:solidFill>
@@ -17623,7 +17624,7 @@
               <a:spcAft>
                 <a:spcPts val="800"/>
               </a:spcAft>
-              <a:defRPr sz="1800">
+              <a:defRPr sz="1600">
                 <a:solidFill>
                   <a:srgbClr val="363A48"/>
                 </a:solidFill>
@@ -17657,7 +17658,7 @@
         </p:spPr>
         <p:txBody>
           <a:bodyPr wrap="square" lIns="64008" rIns="64008" tIns="64008" bIns="64008" anchor="t">
-            <a:spAutoFit/>
+            <a:normAutofit/>
           </a:bodyPr>
           <a:lstStyle/>
           <a:p>
@@ -17699,7 +17700,7 @@
         </p:spPr>
         <p:txBody>
           <a:bodyPr wrap="square" lIns="128016" rIns="128016" tIns="128016" bIns="128016" anchor="t">
-            <a:spAutoFit/>
+            <a:normAutofit/>
           </a:bodyPr>
           <a:lstStyle/>
           <a:p>
@@ -17737,7 +17738,7 @@
         </p:spPr>
         <p:txBody>
           <a:bodyPr wrap="square" lIns="0" rIns="0" tIns="0" bIns="0" anchor="t">
-            <a:spAutoFit/>
+            <a:normAutofit/>
           </a:bodyPr>
           <a:lstStyle/>
           <a:p>
@@ -17779,7 +17780,7 @@
         </p:spPr>
         <p:txBody>
           <a:bodyPr wrap="square" lIns="54864" rIns="54864" tIns="54864" bIns="54864" anchor="t">
-            <a:spAutoFit/>
+            <a:normAutofit/>
           </a:bodyPr>
           <a:lstStyle/>
           <a:p>
@@ -17860,7 +17861,7 @@
         </p:spPr>
         <p:txBody>
           <a:bodyPr wrap="square" lIns="9144" rIns="9144" tIns="9144" bIns="9144" anchor="ctr">
-            <a:spAutoFit/>
+            <a:normAutofit/>
           </a:bodyPr>
           <a:lstStyle/>
           <a:p>
@@ -17898,7 +17899,7 @@
         </p:spPr>
         <p:txBody>
           <a:bodyPr wrap="square" lIns="9144" rIns="9144" tIns="9144" bIns="9144" anchor="t">
-            <a:spAutoFit/>
+            <a:normAutofit/>
           </a:bodyPr>
           <a:lstStyle/>
           <a:p>
@@ -17940,7 +17941,7 @@
         </p:spPr>
         <p:txBody>
           <a:bodyPr wrap="square" lIns="54864" rIns="54864" tIns="54864" bIns="54864" anchor="t">
-            <a:spAutoFit/>
+            <a:normAutofit/>
           </a:bodyPr>
           <a:lstStyle/>
           <a:p>
@@ -18021,7 +18022,7 @@
         </p:spPr>
         <p:txBody>
           <a:bodyPr wrap="square" lIns="9144" rIns="9144" tIns="9144" bIns="9144" anchor="ctr">
-            <a:spAutoFit/>
+            <a:normAutofit/>
           </a:bodyPr>
           <a:lstStyle/>
           <a:p>
@@ -18059,7 +18060,7 @@
         </p:spPr>
         <p:txBody>
           <a:bodyPr wrap="square" lIns="9144" rIns="9144" tIns="9144" bIns="9144" anchor="t">
-            <a:spAutoFit/>
+            <a:normAutofit/>
           </a:bodyPr>
           <a:lstStyle/>
           <a:p>
@@ -18101,7 +18102,7 @@
         </p:spPr>
         <p:txBody>
           <a:bodyPr wrap="square" lIns="54864" rIns="54864" tIns="54864" bIns="54864" anchor="t">
-            <a:spAutoFit/>
+            <a:normAutofit/>
           </a:bodyPr>
           <a:lstStyle/>
           <a:p>
@@ -18182,7 +18183,7 @@
         </p:spPr>
         <p:txBody>
           <a:bodyPr wrap="square" lIns="9144" rIns="9144" tIns="9144" bIns="9144" anchor="ctr">
-            <a:spAutoFit/>
+            <a:normAutofit/>
           </a:bodyPr>
           <a:lstStyle/>
           <a:p>
@@ -18220,7 +18221,7 @@
         </p:spPr>
         <p:txBody>
           <a:bodyPr wrap="square" lIns="9144" rIns="9144" tIns="9144" bIns="9144" anchor="t">
-            <a:spAutoFit/>
+            <a:normAutofit/>
           </a:bodyPr>
           <a:lstStyle/>
           <a:p>
@@ -18262,7 +18263,7 @@
         </p:spPr>
         <p:txBody>
           <a:bodyPr wrap="square" lIns="54864" rIns="54864" tIns="54864" bIns="54864" anchor="t">
-            <a:spAutoFit/>
+            <a:normAutofit/>
           </a:bodyPr>
           <a:lstStyle/>
           <a:p>
@@ -18343,7 +18344,7 @@
         </p:spPr>
         <p:txBody>
           <a:bodyPr wrap="square" lIns="9144" rIns="9144" tIns="9144" bIns="9144" anchor="ctr">
-            <a:spAutoFit/>
+            <a:normAutofit/>
           </a:bodyPr>
           <a:lstStyle/>
           <a:p>
@@ -18381,7 +18382,7 @@
         </p:spPr>
         <p:txBody>
           <a:bodyPr wrap="square" lIns="9144" rIns="9144" tIns="9144" bIns="9144" anchor="t">
-            <a:spAutoFit/>
+            <a:normAutofit/>
           </a:bodyPr>
           <a:lstStyle/>
           <a:p>
@@ -18531,7 +18532,7 @@
         </p:spPr>
         <p:txBody>
           <a:bodyPr wrap="square" lIns="0" rIns="0" tIns="0" bIns="0" anchor="t">
-            <a:spAutoFit/>
+            <a:normAutofit/>
           </a:bodyPr>
           <a:lstStyle/>
           <a:p>
@@ -18573,7 +18574,7 @@
         </p:spPr>
         <p:txBody>
           <a:bodyPr wrap="square" lIns="9144" rIns="9144" tIns="9144" bIns="9144" anchor="ctr">
-            <a:spAutoFit/>
+            <a:normAutofit/>
           </a:bodyPr>
           <a:lstStyle/>
           <a:p>
@@ -18611,7 +18612,7 @@
         </p:spPr>
         <p:txBody>
           <a:bodyPr wrap="square" lIns="0" rIns="0" tIns="0" bIns="0" anchor="ctr">
-            <a:spAutoFit/>
+            <a:normAutofit/>
           </a:bodyPr>
           <a:lstStyle/>
           <a:p>
@@ -18692,7 +18693,7 @@
         </p:spPr>
         <p:txBody>
           <a:bodyPr wrap="square" lIns="0" rIns="0" tIns="0" bIns="0" anchor="t">
-            <a:spAutoFit/>
+            <a:normAutofit/>
           </a:bodyPr>
           <a:lstStyle/>
           <a:p>
@@ -18734,7 +18735,7 @@
         </p:spPr>
         <p:txBody>
           <a:bodyPr wrap="square" lIns="27432" rIns="27432" tIns="27432" bIns="27432" anchor="ctr">
-            <a:spAutoFit/>
+            <a:normAutofit/>
           </a:bodyPr>
           <a:lstStyle/>
           <a:p>
@@ -18776,7 +18777,7 @@
         </p:spPr>
         <p:txBody>
           <a:bodyPr wrap="square" lIns="109728" rIns="109728" tIns="109728" bIns="109728" anchor="t">
-            <a:spAutoFit/>
+            <a:normAutofit/>
           </a:bodyPr>
           <a:lstStyle/>
           <a:p>
@@ -18842,7 +18843,7 @@
         </p:spPr>
         <p:txBody>
           <a:bodyPr wrap="square" lIns="109728" rIns="109728" tIns="109728" bIns="109728" anchor="t">
-            <a:spAutoFit/>
+            <a:normAutofit/>
           </a:bodyPr>
           <a:lstStyle/>
           <a:p>
@@ -18904,7 +18905,7 @@
         </p:spPr>
         <p:txBody>
           <a:bodyPr wrap="square" lIns="64008" rIns="64008" tIns="64008" bIns="64008" anchor="t">
-            <a:spAutoFit/>
+            <a:normAutofit/>
           </a:bodyPr>
           <a:lstStyle/>
           <a:p>
@@ -18942,7 +18943,7 @@
         </p:spPr>
         <p:txBody>
           <a:bodyPr wrap="square" lIns="64008" rIns="64008" tIns="64008" bIns="64008" anchor="t">
-            <a:spAutoFit/>
+            <a:normAutofit/>
           </a:bodyPr>
           <a:lstStyle/>
           <a:p>
@@ -18984,7 +18985,7 @@
         </p:spPr>
         <p:txBody>
           <a:bodyPr wrap="square" lIns="118872" rIns="118872" tIns="118872" bIns="118872" anchor="t">
-            <a:spAutoFit/>
+            <a:normAutofit/>
           </a:bodyPr>
           <a:lstStyle/>
           <a:p>
@@ -19080,7 +19081,7 @@
         </p:spPr>
         <p:txBody>
           <a:bodyPr wrap="square" lIns="64008" rIns="64008" tIns="64008" bIns="64008" anchor="ctr">
-            <a:spAutoFit/>
+            <a:normAutofit/>
           </a:bodyPr>
           <a:lstStyle/>
           <a:p>
@@ -19230,13 +19231,13 @@
         </p:spPr>
         <p:txBody>
           <a:bodyPr wrap="square" lIns="0" rIns="0" tIns="0" bIns="0" anchor="t">
-            <a:spAutoFit/>
+            <a:normAutofit/>
           </a:bodyPr>
           <a:lstStyle/>
           <a:p>
             <a:pPr algn="l"/>
             <a:r>
-              <a:rPr sz="2400" b="1">
+              <a:rPr sz="2100" b="1">
                 <a:solidFill>
                   <a:srgbClr val="282C3A"/>
                 </a:solidFill>
@@ -19272,7 +19273,7 @@
         </p:spPr>
         <p:txBody>
           <a:bodyPr wrap="square" lIns="9144" rIns="9144" tIns="9144" bIns="9144" anchor="ctr">
-            <a:spAutoFit/>
+            <a:normAutofit/>
           </a:bodyPr>
           <a:lstStyle/>
           <a:p>
@@ -19310,7 +19311,7 @@
         </p:spPr>
         <p:txBody>
           <a:bodyPr wrap="square" lIns="0" rIns="0" tIns="0" bIns="0" anchor="ctr">
-            <a:spAutoFit/>
+            <a:normAutofit/>
           </a:bodyPr>
           <a:lstStyle/>
           <a:p>
@@ -19391,7 +19392,7 @@
         </p:spPr>
         <p:txBody>
           <a:bodyPr wrap="square" lIns="0" rIns="0" tIns="0" bIns="0" anchor="t">
-            <a:spAutoFit/>
+            <a:normAutofit/>
           </a:bodyPr>
           <a:lstStyle/>
           <a:p>
@@ -19433,7 +19434,7 @@
         </p:spPr>
         <p:txBody>
           <a:bodyPr wrap="square" lIns="27432" rIns="27432" tIns="27432" bIns="27432" anchor="ctr">
-            <a:spAutoFit/>
+            <a:normAutofit/>
           </a:bodyPr>
           <a:lstStyle/>
           <a:p>
@@ -19475,7 +19476,7 @@
         </p:spPr>
         <p:txBody>
           <a:bodyPr wrap="square" lIns="128016" rIns="128016" tIns="128016" bIns="128016" anchor="t">
-            <a:spAutoFit/>
+            <a:normAutofit/>
           </a:bodyPr>
           <a:lstStyle/>
           <a:p>
@@ -19489,7 +19490,7 @@
               <a:spcAft>
                 <a:spcPts val="800"/>
               </a:spcAft>
-              <a:defRPr sz="1800">
+              <a:defRPr sz="1600">
                 <a:solidFill>
                   <a:srgbClr val="363A48"/>
                 </a:solidFill>
@@ -19511,7 +19512,7 @@
               <a:spcAft>
                 <a:spcPts val="800"/>
               </a:spcAft>
-              <a:defRPr sz="1800">
+              <a:defRPr sz="1600">
                 <a:solidFill>
                   <a:srgbClr val="363A48"/>
                 </a:solidFill>
@@ -19533,7 +19534,7 @@
               <a:spcAft>
                 <a:spcPts val="800"/>
               </a:spcAft>
-              <a:defRPr sz="1800">
+              <a:defRPr sz="1600">
                 <a:solidFill>
                   <a:srgbClr val="363A48"/>
                 </a:solidFill>
@@ -19567,7 +19568,7 @@
         </p:spPr>
         <p:txBody>
           <a:bodyPr wrap="square" lIns="64008" rIns="64008" tIns="64008" bIns="64008" anchor="t">
-            <a:spAutoFit/>
+            <a:normAutofit/>
           </a:bodyPr>
           <a:lstStyle/>
           <a:p>
@@ -19609,7 +19610,7 @@
         </p:spPr>
         <p:txBody>
           <a:bodyPr wrap="square" lIns="128016" rIns="128016" tIns="128016" bIns="128016" anchor="t">
-            <a:spAutoFit/>
+            <a:normAutofit/>
           </a:bodyPr>
           <a:lstStyle/>
           <a:p>
@@ -19647,7 +19648,7 @@
         </p:spPr>
         <p:txBody>
           <a:bodyPr wrap="square" lIns="0" rIns="0" tIns="0" bIns="0" anchor="t">
-            <a:spAutoFit/>
+            <a:normAutofit/>
           </a:bodyPr>
           <a:lstStyle/>
           <a:p>
@@ -19689,7 +19690,7 @@
         </p:spPr>
         <p:txBody>
           <a:bodyPr wrap="square" lIns="54864" rIns="54864" tIns="54864" bIns="54864" anchor="t">
-            <a:spAutoFit/>
+            <a:normAutofit/>
           </a:bodyPr>
           <a:lstStyle/>
           <a:p>
@@ -19770,7 +19771,7 @@
         </p:spPr>
         <p:txBody>
           <a:bodyPr wrap="square" lIns="9144" rIns="9144" tIns="9144" bIns="9144" anchor="ctr">
-            <a:spAutoFit/>
+            <a:normAutofit/>
           </a:bodyPr>
           <a:lstStyle/>
           <a:p>
@@ -19808,7 +19809,7 @@
         </p:spPr>
         <p:txBody>
           <a:bodyPr wrap="square" lIns="9144" rIns="9144" tIns="9144" bIns="9144" anchor="t">
-            <a:spAutoFit/>
+            <a:normAutofit/>
           </a:bodyPr>
           <a:lstStyle/>
           <a:p>
@@ -19850,7 +19851,7 @@
         </p:spPr>
         <p:txBody>
           <a:bodyPr wrap="square" lIns="54864" rIns="54864" tIns="54864" bIns="54864" anchor="t">
-            <a:spAutoFit/>
+            <a:normAutofit/>
           </a:bodyPr>
           <a:lstStyle/>
           <a:p>
@@ -19931,7 +19932,7 @@
         </p:spPr>
         <p:txBody>
           <a:bodyPr wrap="square" lIns="9144" rIns="9144" tIns="9144" bIns="9144" anchor="ctr">
-            <a:spAutoFit/>
+            <a:normAutofit/>
           </a:bodyPr>
           <a:lstStyle/>
           <a:p>
@@ -19969,7 +19970,7 @@
         </p:spPr>
         <p:txBody>
           <a:bodyPr wrap="square" lIns="9144" rIns="9144" tIns="9144" bIns="9144" anchor="t">
-            <a:spAutoFit/>
+            <a:normAutofit/>
           </a:bodyPr>
           <a:lstStyle/>
           <a:p>
@@ -20011,7 +20012,7 @@
         </p:spPr>
         <p:txBody>
           <a:bodyPr wrap="square" lIns="54864" rIns="54864" tIns="54864" bIns="54864" anchor="t">
-            <a:spAutoFit/>
+            <a:normAutofit/>
           </a:bodyPr>
           <a:lstStyle/>
           <a:p>
@@ -20092,7 +20093,7 @@
         </p:spPr>
         <p:txBody>
           <a:bodyPr wrap="square" lIns="9144" rIns="9144" tIns="9144" bIns="9144" anchor="ctr">
-            <a:spAutoFit/>
+            <a:normAutofit/>
           </a:bodyPr>
           <a:lstStyle/>
           <a:p>
@@ -20130,7 +20131,7 @@
         </p:spPr>
         <p:txBody>
           <a:bodyPr wrap="square" lIns="9144" rIns="9144" tIns="9144" bIns="9144" anchor="t">
-            <a:spAutoFit/>
+            <a:normAutofit/>
           </a:bodyPr>
           <a:lstStyle/>
           <a:p>
@@ -20172,7 +20173,7 @@
         </p:spPr>
         <p:txBody>
           <a:bodyPr wrap="square" lIns="54864" rIns="54864" tIns="54864" bIns="54864" anchor="t">
-            <a:spAutoFit/>
+            <a:normAutofit/>
           </a:bodyPr>
           <a:lstStyle/>
           <a:p>
@@ -20253,7 +20254,7 @@
         </p:spPr>
         <p:txBody>
           <a:bodyPr wrap="square" lIns="9144" rIns="9144" tIns="9144" bIns="9144" anchor="ctr">
-            <a:spAutoFit/>
+            <a:normAutofit/>
           </a:bodyPr>
           <a:lstStyle/>
           <a:p>
@@ -20291,7 +20292,7 @@
         </p:spPr>
         <p:txBody>
           <a:bodyPr wrap="square" lIns="9144" rIns="9144" tIns="9144" bIns="9144" anchor="t">
-            <a:spAutoFit/>
+            <a:normAutofit/>
           </a:bodyPr>
           <a:lstStyle/>
           <a:p>
@@ -20441,7 +20442,7 @@
         </p:spPr>
         <p:txBody>
           <a:bodyPr wrap="square" lIns="0" rIns="0" tIns="0" bIns="0" anchor="t">
-            <a:spAutoFit/>
+            <a:normAutofit/>
           </a:bodyPr>
           <a:lstStyle/>
           <a:p>
@@ -20483,7 +20484,7 @@
         </p:spPr>
         <p:txBody>
           <a:bodyPr wrap="square" lIns="9144" rIns="9144" tIns="9144" bIns="9144" anchor="ctr">
-            <a:spAutoFit/>
+            <a:normAutofit/>
           </a:bodyPr>
           <a:lstStyle/>
           <a:p>
@@ -20521,7 +20522,7 @@
         </p:spPr>
         <p:txBody>
           <a:bodyPr wrap="square" lIns="0" rIns="0" tIns="0" bIns="0" anchor="ctr">
-            <a:spAutoFit/>
+            <a:normAutofit/>
           </a:bodyPr>
           <a:lstStyle/>
           <a:p>
@@ -20602,7 +20603,7 @@
         </p:spPr>
         <p:txBody>
           <a:bodyPr wrap="square" lIns="0" rIns="0" tIns="0" bIns="0" anchor="t">
-            <a:spAutoFit/>
+            <a:normAutofit/>
           </a:bodyPr>
           <a:lstStyle/>
           <a:p>
@@ -20644,7 +20645,7 @@
         </p:spPr>
         <p:txBody>
           <a:bodyPr wrap="square" lIns="27432" rIns="27432" tIns="27432" bIns="27432" anchor="ctr">
-            <a:spAutoFit/>
+            <a:normAutofit/>
           </a:bodyPr>
           <a:lstStyle/>
           <a:p>
@@ -20686,7 +20687,7 @@
         </p:spPr>
         <p:txBody>
           <a:bodyPr wrap="square" lIns="64008" rIns="64008" tIns="64008" bIns="64008" anchor="ctr">
-            <a:spAutoFit/>
+            <a:normAutofit/>
           </a:bodyPr>
           <a:lstStyle/>
           <a:p>
@@ -20728,7 +20729,7 @@
         </p:spPr>
         <p:txBody>
           <a:bodyPr wrap="square" lIns="109728" rIns="109728" tIns="109728" bIns="109728" anchor="t">
-            <a:spAutoFit/>
+            <a:normAutofit/>
           </a:bodyPr>
           <a:lstStyle/>
           <a:p>
@@ -20766,7 +20767,7 @@
         </p:spPr>
         <p:txBody>
           <a:bodyPr wrap="square" lIns="0" rIns="0" tIns="0" bIns="0" anchor="t">
-            <a:spAutoFit/>
+            <a:normAutofit/>
           </a:bodyPr>
           <a:lstStyle/>
           <a:p>
@@ -20804,7 +20805,7 @@
         </p:spPr>
         <p:txBody>
           <a:bodyPr wrap="square" lIns="0" rIns="0" tIns="0" bIns="0" anchor="t">
-            <a:spAutoFit/>
+            <a:normAutofit/>
           </a:bodyPr>
           <a:lstStyle/>
           <a:p>
@@ -20846,7 +20847,7 @@
         </p:spPr>
         <p:txBody>
           <a:bodyPr wrap="square" lIns="109728" rIns="109728" tIns="109728" bIns="109728" anchor="t">
-            <a:spAutoFit/>
+            <a:normAutofit/>
           </a:bodyPr>
           <a:lstStyle/>
           <a:p>
@@ -20884,7 +20885,7 @@
         </p:spPr>
         <p:txBody>
           <a:bodyPr wrap="square" lIns="0" rIns="0" tIns="0" bIns="0" anchor="t">
-            <a:spAutoFit/>
+            <a:normAutofit/>
           </a:bodyPr>
           <a:lstStyle/>
           <a:p>
@@ -20922,7 +20923,7 @@
         </p:spPr>
         <p:txBody>
           <a:bodyPr wrap="square" lIns="0" rIns="0" tIns="0" bIns="0" anchor="t">
-            <a:spAutoFit/>
+            <a:normAutofit/>
           </a:bodyPr>
           <a:lstStyle/>
           <a:p>
@@ -20964,7 +20965,7 @@
         </p:spPr>
         <p:txBody>
           <a:bodyPr wrap="square" lIns="109728" rIns="109728" tIns="109728" bIns="109728" anchor="t">
-            <a:spAutoFit/>
+            <a:normAutofit/>
           </a:bodyPr>
           <a:lstStyle/>
           <a:p>
@@ -21002,7 +21003,7 @@
         </p:spPr>
         <p:txBody>
           <a:bodyPr wrap="square" lIns="0" rIns="0" tIns="0" bIns="0" anchor="t">
-            <a:spAutoFit/>
+            <a:normAutofit/>
           </a:bodyPr>
           <a:lstStyle/>
           <a:p>
@@ -21040,7 +21041,7 @@
         </p:spPr>
         <p:txBody>
           <a:bodyPr wrap="square" lIns="0" rIns="0" tIns="0" bIns="0" anchor="t">
-            <a:spAutoFit/>
+            <a:normAutofit/>
           </a:bodyPr>
           <a:lstStyle/>
           <a:p>
@@ -21082,7 +21083,7 @@
         </p:spPr>
         <p:txBody>
           <a:bodyPr wrap="square" lIns="118872" rIns="118872" tIns="118872" bIns="118872" anchor="t">
-            <a:spAutoFit/>
+            <a:normAutofit/>
           </a:bodyPr>
           <a:lstStyle/>
           <a:p>
@@ -21242,13 +21243,13 @@
         </p:spPr>
         <p:txBody>
           <a:bodyPr wrap="square" lIns="0" rIns="0" tIns="0" bIns="0" anchor="t">
-            <a:spAutoFit/>
+            <a:normAutofit/>
           </a:bodyPr>
           <a:lstStyle/>
           <a:p>
             <a:pPr algn="l"/>
             <a:r>
-              <a:rPr sz="2400" b="1">
+              <a:rPr sz="2200" b="1">
                 <a:solidFill>
                   <a:srgbClr val="282C3A"/>
                 </a:solidFill>
@@ -21284,7 +21285,7 @@
         </p:spPr>
         <p:txBody>
           <a:bodyPr wrap="square" lIns="9144" rIns="9144" tIns="9144" bIns="9144" anchor="ctr">
-            <a:spAutoFit/>
+            <a:normAutofit/>
           </a:bodyPr>
           <a:lstStyle/>
           <a:p>
@@ -21322,7 +21323,7 @@
         </p:spPr>
         <p:txBody>
           <a:bodyPr wrap="square" lIns="0" rIns="0" tIns="0" bIns="0" anchor="ctr">
-            <a:spAutoFit/>
+            <a:normAutofit/>
           </a:bodyPr>
           <a:lstStyle/>
           <a:p>
@@ -21403,7 +21404,7 @@
         </p:spPr>
         <p:txBody>
           <a:bodyPr wrap="square" lIns="0" rIns="0" tIns="0" bIns="0" anchor="t">
-            <a:spAutoFit/>
+            <a:normAutofit/>
           </a:bodyPr>
           <a:lstStyle/>
           <a:p>
@@ -21445,7 +21446,7 @@
         </p:spPr>
         <p:txBody>
           <a:bodyPr wrap="square" lIns="27432" rIns="27432" tIns="27432" bIns="27432" anchor="ctr">
-            <a:spAutoFit/>
+            <a:normAutofit/>
           </a:bodyPr>
           <a:lstStyle/>
           <a:p>
@@ -21487,7 +21488,7 @@
         </p:spPr>
         <p:txBody>
           <a:bodyPr wrap="square" lIns="64008" rIns="64008" tIns="64008" bIns="64008" anchor="ctr">
-            <a:spAutoFit/>
+            <a:normAutofit/>
           </a:bodyPr>
           <a:lstStyle/>
           <a:p>
@@ -21529,7 +21530,7 @@
         </p:spPr>
         <p:txBody>
           <a:bodyPr wrap="square" lIns="109728" rIns="109728" tIns="109728" bIns="109728" anchor="t">
-            <a:spAutoFit/>
+            <a:normAutofit/>
           </a:bodyPr>
           <a:lstStyle/>
           <a:p>
@@ -21567,7 +21568,7 @@
         </p:spPr>
         <p:txBody>
           <a:bodyPr wrap="square" lIns="0" rIns="0" tIns="0" bIns="0" anchor="t">
-            <a:spAutoFit/>
+            <a:normAutofit/>
           </a:bodyPr>
           <a:lstStyle/>
           <a:p>
@@ -21605,7 +21606,7 @@
         </p:spPr>
         <p:txBody>
           <a:bodyPr wrap="square" lIns="0" rIns="0" tIns="0" bIns="0" anchor="t">
-            <a:spAutoFit/>
+            <a:normAutofit/>
           </a:bodyPr>
           <a:lstStyle/>
           <a:p>
@@ -21647,7 +21648,7 @@
         </p:spPr>
         <p:txBody>
           <a:bodyPr wrap="square" lIns="109728" rIns="109728" tIns="109728" bIns="109728" anchor="t">
-            <a:spAutoFit/>
+            <a:normAutofit/>
           </a:bodyPr>
           <a:lstStyle/>
           <a:p>
@@ -21685,7 +21686,7 @@
         </p:spPr>
         <p:txBody>
           <a:bodyPr wrap="square" lIns="0" rIns="0" tIns="0" bIns="0" anchor="t">
-            <a:spAutoFit/>
+            <a:normAutofit/>
           </a:bodyPr>
           <a:lstStyle/>
           <a:p>
@@ -21723,7 +21724,7 @@
         </p:spPr>
         <p:txBody>
           <a:bodyPr wrap="square" lIns="0" rIns="0" tIns="0" bIns="0" anchor="t">
-            <a:spAutoFit/>
+            <a:normAutofit/>
           </a:bodyPr>
           <a:lstStyle/>
           <a:p>
@@ -21765,7 +21766,7 @@
         </p:spPr>
         <p:txBody>
           <a:bodyPr wrap="square" lIns="109728" rIns="109728" tIns="109728" bIns="109728" anchor="t">
-            <a:spAutoFit/>
+            <a:normAutofit/>
           </a:bodyPr>
           <a:lstStyle/>
           <a:p>
@@ -21803,7 +21804,7 @@
         </p:spPr>
         <p:txBody>
           <a:bodyPr wrap="square" lIns="0" rIns="0" tIns="0" bIns="0" anchor="t">
-            <a:spAutoFit/>
+            <a:normAutofit/>
           </a:bodyPr>
           <a:lstStyle/>
           <a:p>
@@ -21841,7 +21842,7 @@
         </p:spPr>
         <p:txBody>
           <a:bodyPr wrap="square" lIns="0" rIns="0" tIns="0" bIns="0" anchor="t">
-            <a:spAutoFit/>
+            <a:normAutofit/>
           </a:bodyPr>
           <a:lstStyle/>
           <a:p>
@@ -21883,7 +21884,7 @@
         </p:spPr>
         <p:txBody>
           <a:bodyPr wrap="square" lIns="109728" rIns="109728" tIns="109728" bIns="109728" anchor="t">
-            <a:spAutoFit/>
+            <a:normAutofit/>
           </a:bodyPr>
           <a:lstStyle/>
           <a:p>
@@ -21921,7 +21922,7 @@
         </p:spPr>
         <p:txBody>
           <a:bodyPr wrap="square" lIns="0" rIns="0" tIns="0" bIns="0" anchor="t">
-            <a:spAutoFit/>
+            <a:normAutofit/>
           </a:bodyPr>
           <a:lstStyle/>
           <a:p>
@@ -21959,7 +21960,7 @@
         </p:spPr>
         <p:txBody>
           <a:bodyPr wrap="square" lIns="0" rIns="0" tIns="0" bIns="0" anchor="t">
-            <a:spAutoFit/>
+            <a:normAutofit/>
           </a:bodyPr>
           <a:lstStyle/>
           <a:p>
@@ -22001,7 +22002,7 @@
         </p:spPr>
         <p:txBody>
           <a:bodyPr wrap="square" lIns="118872" rIns="118872" tIns="118872" bIns="118872" anchor="t">
-            <a:spAutoFit/>
+            <a:normAutofit/>
           </a:bodyPr>
           <a:lstStyle/>
           <a:p>
@@ -22205,7 +22206,7 @@
         </p:spPr>
         <p:txBody>
           <a:bodyPr wrap="square" lIns="0" rIns="0" tIns="0" bIns="0" anchor="t">
-            <a:spAutoFit/>
+            <a:normAutofit/>
           </a:bodyPr>
           <a:lstStyle/>
           <a:p>
@@ -22247,7 +22248,7 @@
         </p:spPr>
         <p:txBody>
           <a:bodyPr wrap="square" lIns="9144" rIns="9144" tIns="9144" bIns="9144" anchor="ctr">
-            <a:spAutoFit/>
+            <a:normAutofit/>
           </a:bodyPr>
           <a:lstStyle/>
           <a:p>
@@ -22285,7 +22286,7 @@
         </p:spPr>
         <p:txBody>
           <a:bodyPr wrap="square" lIns="0" rIns="0" tIns="0" bIns="0" anchor="ctr">
-            <a:spAutoFit/>
+            <a:normAutofit/>
           </a:bodyPr>
           <a:lstStyle/>
           <a:p>
@@ -22366,7 +22367,7 @@
         </p:spPr>
         <p:txBody>
           <a:bodyPr wrap="square" lIns="0" rIns="0" tIns="0" bIns="0" anchor="t">
-            <a:spAutoFit/>
+            <a:normAutofit/>
           </a:bodyPr>
           <a:lstStyle/>
           <a:p>
@@ -22408,7 +22409,7 @@
         </p:spPr>
         <p:txBody>
           <a:bodyPr wrap="square" lIns="27432" rIns="27432" tIns="27432" bIns="27432" anchor="ctr">
-            <a:spAutoFit/>
+            <a:normAutofit/>
           </a:bodyPr>
           <a:lstStyle/>
           <a:p>
@@ -22450,7 +22451,7 @@
         </p:spPr>
         <p:txBody>
           <a:bodyPr wrap="square" lIns="109728" rIns="109728" tIns="109728" bIns="109728" anchor="t">
-            <a:spAutoFit/>
+            <a:normAutofit/>
           </a:bodyPr>
           <a:lstStyle/>
           <a:p>
@@ -22516,7 +22517,7 @@
         </p:spPr>
         <p:txBody>
           <a:bodyPr wrap="square" lIns="109728" rIns="109728" tIns="109728" bIns="109728" anchor="t">
-            <a:spAutoFit/>
+            <a:normAutofit/>
           </a:bodyPr>
           <a:lstStyle/>
           <a:p>
@@ -22578,7 +22579,7 @@
         </p:spPr>
         <p:txBody>
           <a:bodyPr wrap="square" lIns="64008" rIns="64008" tIns="64008" bIns="64008" anchor="t">
-            <a:spAutoFit/>
+            <a:normAutofit/>
           </a:bodyPr>
           <a:lstStyle/>
           <a:p>
@@ -22616,7 +22617,7 @@
         </p:spPr>
         <p:txBody>
           <a:bodyPr wrap="square" lIns="64008" rIns="64008" tIns="64008" bIns="64008" anchor="t">
-            <a:spAutoFit/>
+            <a:normAutofit/>
           </a:bodyPr>
           <a:lstStyle/>
           <a:p>
@@ -22658,7 +22659,7 @@
         </p:spPr>
         <p:txBody>
           <a:bodyPr wrap="square" lIns="118872" rIns="118872" tIns="118872" bIns="118872" anchor="t">
-            <a:spAutoFit/>
+            <a:normAutofit/>
           </a:bodyPr>
           <a:lstStyle/>
           <a:p>
@@ -22754,7 +22755,7 @@
         </p:spPr>
         <p:txBody>
           <a:bodyPr wrap="square" lIns="64008" rIns="64008" tIns="64008" bIns="64008" anchor="ctr">
-            <a:spAutoFit/>
+            <a:normAutofit/>
           </a:bodyPr>
           <a:lstStyle/>
           <a:p>
@@ -22904,7 +22905,7 @@
         </p:spPr>
         <p:txBody>
           <a:bodyPr wrap="square" lIns="0" rIns="0" tIns="0" bIns="0" anchor="t">
-            <a:spAutoFit/>
+            <a:normAutofit/>
           </a:bodyPr>
           <a:lstStyle/>
           <a:p>
@@ -22946,7 +22947,7 @@
         </p:spPr>
         <p:txBody>
           <a:bodyPr wrap="square" lIns="9144" rIns="9144" tIns="9144" bIns="9144" anchor="ctr">
-            <a:spAutoFit/>
+            <a:normAutofit/>
           </a:bodyPr>
           <a:lstStyle/>
           <a:p>
@@ -22984,7 +22985,7 @@
         </p:spPr>
         <p:txBody>
           <a:bodyPr wrap="square" lIns="0" rIns="0" tIns="0" bIns="0" anchor="ctr">
-            <a:spAutoFit/>
+            <a:normAutofit/>
           </a:bodyPr>
           <a:lstStyle/>
           <a:p>
@@ -23065,7 +23066,7 @@
         </p:spPr>
         <p:txBody>
           <a:bodyPr wrap="square" lIns="0" rIns="0" tIns="0" bIns="0" anchor="t">
-            <a:spAutoFit/>
+            <a:normAutofit/>
           </a:bodyPr>
           <a:lstStyle/>
           <a:p>
@@ -23107,7 +23108,7 @@
         </p:spPr>
         <p:txBody>
           <a:bodyPr wrap="square" lIns="27432" rIns="27432" tIns="27432" bIns="27432" anchor="ctr">
-            <a:spAutoFit/>
+            <a:normAutofit/>
           </a:bodyPr>
           <a:lstStyle/>
           <a:p>
@@ -23149,7 +23150,7 @@
         </p:spPr>
         <p:txBody>
           <a:bodyPr wrap="square" lIns="64008" rIns="64008" tIns="64008" bIns="64008" anchor="ctr">
-            <a:spAutoFit/>
+            <a:normAutofit/>
           </a:bodyPr>
           <a:lstStyle/>
           <a:p>
@@ -23191,7 +23192,7 @@
         </p:spPr>
         <p:txBody>
           <a:bodyPr wrap="square" lIns="118872" rIns="118872" tIns="118872" bIns="118872" anchor="t">
-            <a:spAutoFit/>
+            <a:normAutofit/>
           </a:bodyPr>
           <a:lstStyle/>
           <a:p>
@@ -23229,7 +23230,7 @@
         </p:spPr>
         <p:txBody>
           <a:bodyPr wrap="square" lIns="0" rIns="0" tIns="0" bIns="0" anchor="t">
-            <a:spAutoFit/>
+            <a:normAutofit/>
           </a:bodyPr>
           <a:lstStyle/>
           <a:p>
@@ -23267,7 +23268,7 @@
         </p:spPr>
         <p:txBody>
           <a:bodyPr wrap="square" lIns="0" rIns="0" tIns="0" bIns="0" anchor="t">
-            <a:spAutoFit/>
+            <a:normAutofit/>
           </a:bodyPr>
           <a:lstStyle/>
           <a:p>
@@ -23363,7 +23364,7 @@
         </p:spPr>
         <p:txBody>
           <a:bodyPr wrap="square" lIns="118872" rIns="118872" tIns="118872" bIns="118872" anchor="t">
-            <a:spAutoFit/>
+            <a:normAutofit/>
           </a:bodyPr>
           <a:lstStyle/>
           <a:p>
@@ -23401,7 +23402,7 @@
         </p:spPr>
         <p:txBody>
           <a:bodyPr wrap="square" lIns="0" rIns="0" tIns="0" bIns="0" anchor="t">
-            <a:spAutoFit/>
+            <a:normAutofit/>
           </a:bodyPr>
           <a:lstStyle/>
           <a:p>
@@ -23439,7 +23440,7 @@
         </p:spPr>
         <p:txBody>
           <a:bodyPr wrap="square" lIns="0" rIns="0" tIns="0" bIns="0" anchor="t">
-            <a:spAutoFit/>
+            <a:normAutofit/>
           </a:bodyPr>
           <a:lstStyle/>
           <a:p>
@@ -23643,13 +23644,13 @@
         </p:spPr>
         <p:txBody>
           <a:bodyPr wrap="square" lIns="0" rIns="0" tIns="0" bIns="0" anchor="t">
-            <a:spAutoFit/>
+            <a:normAutofit/>
           </a:bodyPr>
           <a:lstStyle/>
           <a:p>
             <a:pPr algn="l"/>
             <a:r>
-              <a:rPr sz="2400" b="1">
+              <a:rPr sz="2200" b="1">
                 <a:solidFill>
                   <a:srgbClr val="282C3A"/>
                 </a:solidFill>
@@ -23685,7 +23686,7 @@
         </p:spPr>
         <p:txBody>
           <a:bodyPr wrap="square" lIns="9144" rIns="9144" tIns="9144" bIns="9144" anchor="ctr">
-            <a:spAutoFit/>
+            <a:normAutofit/>
           </a:bodyPr>
           <a:lstStyle/>
           <a:p>
@@ -23723,7 +23724,7 @@
         </p:spPr>
         <p:txBody>
           <a:bodyPr wrap="square" lIns="0" rIns="0" tIns="0" bIns="0" anchor="ctr">
-            <a:spAutoFit/>
+            <a:normAutofit/>
           </a:bodyPr>
           <a:lstStyle/>
           <a:p>
@@ -23804,7 +23805,7 @@
         </p:spPr>
         <p:txBody>
           <a:bodyPr wrap="square" lIns="0" rIns="0" tIns="0" bIns="0" anchor="t">
-            <a:spAutoFit/>
+            <a:normAutofit/>
           </a:bodyPr>
           <a:lstStyle/>
           <a:p>
@@ -23846,7 +23847,7 @@
         </p:spPr>
         <p:txBody>
           <a:bodyPr wrap="square" lIns="27432" rIns="27432" tIns="27432" bIns="27432" anchor="ctr">
-            <a:spAutoFit/>
+            <a:normAutofit/>
           </a:bodyPr>
           <a:lstStyle/>
           <a:p>
@@ -23888,7 +23889,7 @@
         </p:spPr>
         <p:txBody>
           <a:bodyPr wrap="square" lIns="128016" rIns="128016" tIns="128016" bIns="128016" anchor="t">
-            <a:spAutoFit/>
+            <a:normAutofit/>
           </a:bodyPr>
           <a:lstStyle/>
           <a:p>
@@ -23902,7 +23903,7 @@
               <a:spcAft>
                 <a:spcPts val="800"/>
               </a:spcAft>
-              <a:defRPr sz="1800">
+              <a:defRPr sz="1600">
                 <a:solidFill>
                   <a:srgbClr val="363A48"/>
                 </a:solidFill>
@@ -23924,7 +23925,7 @@
               <a:spcAft>
                 <a:spcPts val="800"/>
               </a:spcAft>
-              <a:defRPr sz="1800">
+              <a:defRPr sz="1600">
                 <a:solidFill>
                   <a:srgbClr val="363A48"/>
                 </a:solidFill>
@@ -23946,7 +23947,7 @@
               <a:spcAft>
                 <a:spcPts val="800"/>
               </a:spcAft>
-              <a:defRPr sz="1800">
+              <a:defRPr sz="1600">
                 <a:solidFill>
                   <a:srgbClr val="363A48"/>
                 </a:solidFill>
@@ -23980,7 +23981,7 @@
         </p:spPr>
         <p:txBody>
           <a:bodyPr wrap="square" lIns="64008" rIns="64008" tIns="64008" bIns="64008" anchor="t">
-            <a:spAutoFit/>
+            <a:normAutofit/>
           </a:bodyPr>
           <a:lstStyle/>
           <a:p>
@@ -24022,7 +24023,7 @@
         </p:spPr>
         <p:txBody>
           <a:bodyPr wrap="square" lIns="128016" rIns="128016" tIns="128016" bIns="128016" anchor="t">
-            <a:spAutoFit/>
+            <a:normAutofit/>
           </a:bodyPr>
           <a:lstStyle/>
           <a:p>
@@ -24060,7 +24061,7 @@
         </p:spPr>
         <p:txBody>
           <a:bodyPr wrap="square" lIns="0" rIns="0" tIns="0" bIns="0" anchor="t">
-            <a:spAutoFit/>
+            <a:normAutofit/>
           </a:bodyPr>
           <a:lstStyle/>
           <a:p>
@@ -24102,7 +24103,7 @@
         </p:spPr>
         <p:txBody>
           <a:bodyPr wrap="square" lIns="54864" rIns="54864" tIns="54864" bIns="54864" anchor="t">
-            <a:spAutoFit/>
+            <a:normAutofit/>
           </a:bodyPr>
           <a:lstStyle/>
           <a:p>
@@ -24183,7 +24184,7 @@
         </p:spPr>
         <p:txBody>
           <a:bodyPr wrap="square" lIns="9144" rIns="9144" tIns="9144" bIns="9144" anchor="ctr">
-            <a:spAutoFit/>
+            <a:normAutofit/>
           </a:bodyPr>
           <a:lstStyle/>
           <a:p>
@@ -24221,7 +24222,7 @@
         </p:spPr>
         <p:txBody>
           <a:bodyPr wrap="square" lIns="9144" rIns="9144" tIns="9144" bIns="9144" anchor="t">
-            <a:spAutoFit/>
+            <a:normAutofit/>
           </a:bodyPr>
           <a:lstStyle/>
           <a:p>
@@ -24263,7 +24264,7 @@
         </p:spPr>
         <p:txBody>
           <a:bodyPr wrap="square" lIns="54864" rIns="54864" tIns="54864" bIns="54864" anchor="t">
-            <a:spAutoFit/>
+            <a:normAutofit/>
           </a:bodyPr>
           <a:lstStyle/>
           <a:p>
@@ -24344,7 +24345,7 @@
         </p:spPr>
         <p:txBody>
           <a:bodyPr wrap="square" lIns="9144" rIns="9144" tIns="9144" bIns="9144" anchor="ctr">
-            <a:spAutoFit/>
+            <a:normAutofit/>
           </a:bodyPr>
           <a:lstStyle/>
           <a:p>
@@ -24382,7 +24383,7 @@
         </p:spPr>
         <p:txBody>
           <a:bodyPr wrap="square" lIns="9144" rIns="9144" tIns="9144" bIns="9144" anchor="t">
-            <a:spAutoFit/>
+            <a:normAutofit/>
           </a:bodyPr>
           <a:lstStyle/>
           <a:p>
@@ -24424,7 +24425,7 @@
         </p:spPr>
         <p:txBody>
           <a:bodyPr wrap="square" lIns="54864" rIns="54864" tIns="54864" bIns="54864" anchor="t">
-            <a:spAutoFit/>
+            <a:normAutofit/>
           </a:bodyPr>
           <a:lstStyle/>
           <a:p>
@@ -24505,7 +24506,7 @@
         </p:spPr>
         <p:txBody>
           <a:bodyPr wrap="square" lIns="9144" rIns="9144" tIns="9144" bIns="9144" anchor="ctr">
-            <a:spAutoFit/>
+            <a:normAutofit/>
           </a:bodyPr>
           <a:lstStyle/>
           <a:p>
@@ -24543,7 +24544,7 @@
         </p:spPr>
         <p:txBody>
           <a:bodyPr wrap="square" lIns="9144" rIns="9144" tIns="9144" bIns="9144" anchor="t">
-            <a:spAutoFit/>
+            <a:normAutofit/>
           </a:bodyPr>
           <a:lstStyle/>
           <a:p>
@@ -24585,7 +24586,7 @@
         </p:spPr>
         <p:txBody>
           <a:bodyPr wrap="square" lIns="54864" rIns="54864" tIns="54864" bIns="54864" anchor="t">
-            <a:spAutoFit/>
+            <a:normAutofit/>
           </a:bodyPr>
           <a:lstStyle/>
           <a:p>
@@ -24666,7 +24667,7 @@
         </p:spPr>
         <p:txBody>
           <a:bodyPr wrap="square" lIns="9144" rIns="9144" tIns="9144" bIns="9144" anchor="ctr">
-            <a:spAutoFit/>
+            <a:normAutofit/>
           </a:bodyPr>
           <a:lstStyle/>
           <a:p>
@@ -24704,7 +24705,7 @@
         </p:spPr>
         <p:txBody>
           <a:bodyPr wrap="square" lIns="9144" rIns="9144" tIns="9144" bIns="9144" anchor="t">
-            <a:spAutoFit/>
+            <a:normAutofit/>
           </a:bodyPr>
           <a:lstStyle/>
           <a:p>

</xml_diff>